<commit_message>
Add the design slides, a roadmap template, and the screens in both themes
Three slides on the end of the deck: the logo system and the palette with each
colour named for the one job it does; the portfolio screen side by side in both
themes; and a "What's next" slide left as a template to fill in.

The portfolio and data screens are saved at 2x in both themes under docs/screens.

Co-Authored-By: Claude Opus 5 <noreply@anthropic.com>
Claude-Session: https://claude.ai/code/session_01FAfQiDa3Xfo5qzKcvsbnuE
</commit_message>
<xml_diff>
--- a/docs/Project Glass — PMO Portfolio Tracker.pptx
+++ b/docs/Project Glass — PMO Portfolio Tracker.pptx
@@ -20,9 +20,12 @@
     <p:sldId id="268" r:id="rId14"/>
     <p:sldId id="269" r:id="rId15"/>
     <p:sldId id="270" r:id="rId16"/>
+    <p:sldId id="271" r:id="rId17"/>
+    <p:sldId id="272" r:id="rId18"/>
+    <p:sldId id="273" r:id="rId19"/>
   </p:sldIdLst>
   <p:notesMasterIdLst>
-    <p:notesMasterId r:id="rId17"/>
+    <p:notesMasterId r:id="rId20"/>
   </p:notesMasterIdLst>
   <p:sldSz cx="12192000" cy="6858000"/>
   <p:notesSz cx="6858000" cy="12192000"/>
@@ -1044,7 +1047,7 @@
           <a:p>
             <a:r>
               <a:rPr lang="en-US" dirty="0"/>
-              <a:t>Close on the ask. The tool is in use today on a single machine; the one thing standing between that and team-wide use is shared storage, which is specified and about a day of work.</a:t>
+              <a:t>The palette is not decoration: every colour has one job, which is why the screens stay readable when twenty-eight projects are on one chart. Teal appears once per screen at most — it is the highlight, not a second brand colour.</a:t>
             </a:r>
             <a:endParaRPr lang="en-US" dirty="0"/>
           </a:p>
@@ -1068,6 +1071,270 @@
             <a:fld id="{F7021451-1387-4CA6-816F-3879F97B5CBC}" type="slidenum">
               <a:rPr lang="en-US"/>
               <a:t>15</a:t>
+            </a:fld>
+            <a:endParaRPr lang="en-US"/>
+          </a:p>
+        </p:txBody>
+      </p:sp>
+    </p:spTree>
+    <p:extLst>
+      <p:ext uri="{BB962C8B-B14F-4D97-AF65-F5344CB8AC3E}">
+        <p14:creationId xmlns:p14="http://schemas.microsoft.com/office/powerpoint/2010/main" val="1024086991"/>
+      </p:ext>
+    </p:extLst>
+  </p:cSld>
+  <p:clrMapOvr>
+    <a:masterClrMapping/>
+  </p:clrMapOvr>
+</p:notes>
+</file>
+
+<file path=ppt/notesSlides/notesSlide16.xml><?xml version="1.0" encoding="utf-8"?>
+<p:notes xmlns:a="http://schemas.openxmlformats.org/drawingml/2006/main" xmlns:r="http://schemas.openxmlformats.org/officeDocument/2006/relationships" xmlns:p="http://schemas.openxmlformats.org/presentationml/2006/main">
+  <p:cSld>
+    <p:spTree>
+      <p:nvGrpSpPr>
+        <p:cNvPr id="1" name=""/>
+        <p:cNvGrpSpPr/>
+        <p:nvPr/>
+      </p:nvGrpSpPr>
+      <p:grpSpPr>
+        <a:xfrm>
+          <a:off x="0" y="0"/>
+          <a:ext cx="0" cy="0"/>
+          <a:chOff x="0" y="0"/>
+          <a:chExt cx="0" cy="0"/>
+        </a:xfrm>
+      </p:grpSpPr>
+      <p:sp>
+        <p:nvSpPr>
+          <p:cNvPr id="2" name="Slide Image Placeholder 1"/>
+          <p:cNvSpPr>
+            <a:spLocks noGrp="1" noRot="1" noChangeAspect="1"/>
+          </p:cNvSpPr>
+          <p:nvPr>
+            <p:ph type="sldImg"/>
+          </p:nvPr>
+        </p:nvSpPr>
+        <p:spPr/>
+      </p:sp>
+      <p:sp>
+        <p:nvSpPr>
+          <p:cNvPr id="3" name="Notes Placeholder 2"/>
+          <p:cNvSpPr>
+            <a:spLocks noGrp="1"/>
+          </p:cNvSpPr>
+          <p:nvPr>
+            <p:ph type="body" idx="1"/>
+          </p:nvPr>
+        </p:nvSpPr>
+        <p:spPr/>
+        <p:txBody>
+          <a:bodyPr/>
+          <a:lstStyle/>
+          <a:p>
+            <a:r>
+              <a:rPr lang="en-US" dirty="0"/>
+              <a:t>Worth saying out loud: the dark theme was not eyeballed. Every rendered piece of text on every screen and tab was measured against the colour it actually sits on, and the two that failed were fixed. The data screen and the tables turn over the same way.</a:t>
+            </a:r>
+            <a:endParaRPr lang="en-US" dirty="0"/>
+          </a:p>
+        </p:txBody>
+      </p:sp>
+      <p:sp>
+        <p:nvSpPr>
+          <p:cNvPr id="4" name="Slide Number Placeholder 3"/>
+          <p:cNvSpPr>
+            <a:spLocks noGrp="1"/>
+          </p:cNvSpPr>
+          <p:nvPr>
+            <p:ph type="sldNum" sz="quarter" idx="10"/>
+          </p:nvPr>
+        </p:nvSpPr>
+        <p:spPr/>
+        <p:txBody>
+          <a:bodyPr/>
+          <a:lstStyle/>
+          <a:p>
+            <a:fld id="{F7021451-1387-4CA6-816F-3879F97B5CBC}" type="slidenum">
+              <a:rPr lang="en-US"/>
+              <a:t>16</a:t>
+            </a:fld>
+            <a:endParaRPr lang="en-US"/>
+          </a:p>
+        </p:txBody>
+      </p:sp>
+    </p:spTree>
+    <p:extLst>
+      <p:ext uri="{BB962C8B-B14F-4D97-AF65-F5344CB8AC3E}">
+        <p14:creationId xmlns:p14="http://schemas.microsoft.com/office/powerpoint/2010/main" val="1024086991"/>
+      </p:ext>
+    </p:extLst>
+  </p:cSld>
+  <p:clrMapOvr>
+    <a:masterClrMapping/>
+  </p:clrMapOvr>
+</p:notes>
+</file>
+
+<file path=ppt/notesSlides/notesSlide17.xml><?xml version="1.0" encoding="utf-8"?>
+<p:notes xmlns:a="http://schemas.openxmlformats.org/drawingml/2006/main" xmlns:r="http://schemas.openxmlformats.org/officeDocument/2006/relationships" xmlns:p="http://schemas.openxmlformats.org/presentationml/2006/main">
+  <p:cSld>
+    <p:spTree>
+      <p:nvGrpSpPr>
+        <p:cNvPr id="1" name=""/>
+        <p:cNvGrpSpPr/>
+        <p:nvPr/>
+      </p:nvGrpSpPr>
+      <p:grpSpPr>
+        <a:xfrm>
+          <a:off x="0" y="0"/>
+          <a:ext cx="0" cy="0"/>
+          <a:chOff x="0" y="0"/>
+          <a:chExt cx="0" cy="0"/>
+        </a:xfrm>
+      </p:grpSpPr>
+      <p:sp>
+        <p:nvSpPr>
+          <p:cNvPr id="2" name="Slide Image Placeholder 1"/>
+          <p:cNvSpPr>
+            <a:spLocks noGrp="1" noRot="1" noChangeAspect="1"/>
+          </p:cNvSpPr>
+          <p:nvPr>
+            <p:ph type="sldImg"/>
+          </p:nvPr>
+        </p:nvSpPr>
+        <p:spPr/>
+      </p:sp>
+      <p:sp>
+        <p:nvSpPr>
+          <p:cNvPr id="3" name="Notes Placeholder 2"/>
+          <p:cNvSpPr>
+            <a:spLocks noGrp="1"/>
+          </p:cNvSpPr>
+          <p:nvPr>
+            <p:ph type="body" idx="1"/>
+          </p:nvPr>
+        </p:nvSpPr>
+        <p:spPr/>
+        <p:txBody>
+          <a:bodyPr/>
+          <a:lstStyle/>
+          <a:p>
+            <a:r>
+              <a:rPr lang="en-US" dirty="0"/>
+              <a:t>Placeholder slide — the headings and body text are here to be replaced. The one item already specified and costed is shared storage, so the portfolio follows you between machines rather than living in one browser: roughly a day of work, with the options written up in the repository under docs/shared-data-options.md.</a:t>
+            </a:r>
+            <a:endParaRPr lang="en-US" dirty="0"/>
+          </a:p>
+        </p:txBody>
+      </p:sp>
+      <p:sp>
+        <p:nvSpPr>
+          <p:cNvPr id="4" name="Slide Number Placeholder 3"/>
+          <p:cNvSpPr>
+            <a:spLocks noGrp="1"/>
+          </p:cNvSpPr>
+          <p:nvPr>
+            <p:ph type="sldNum" sz="quarter" idx="10"/>
+          </p:nvPr>
+        </p:nvSpPr>
+        <p:spPr/>
+        <p:txBody>
+          <a:bodyPr/>
+          <a:lstStyle/>
+          <a:p>
+            <a:fld id="{F7021451-1387-4CA6-816F-3879F97B5CBC}" type="slidenum">
+              <a:rPr lang="en-US"/>
+              <a:t>17</a:t>
+            </a:fld>
+            <a:endParaRPr lang="en-US"/>
+          </a:p>
+        </p:txBody>
+      </p:sp>
+    </p:spTree>
+    <p:extLst>
+      <p:ext uri="{BB962C8B-B14F-4D97-AF65-F5344CB8AC3E}">
+        <p14:creationId xmlns:p14="http://schemas.microsoft.com/office/powerpoint/2010/main" val="1024086991"/>
+      </p:ext>
+    </p:extLst>
+  </p:cSld>
+  <p:clrMapOvr>
+    <a:masterClrMapping/>
+  </p:clrMapOvr>
+</p:notes>
+</file>
+
+<file path=ppt/notesSlides/notesSlide18.xml><?xml version="1.0" encoding="utf-8"?>
+<p:notes xmlns:a="http://schemas.openxmlformats.org/drawingml/2006/main" xmlns:r="http://schemas.openxmlformats.org/officeDocument/2006/relationships" xmlns:p="http://schemas.openxmlformats.org/presentationml/2006/main">
+  <p:cSld>
+    <p:spTree>
+      <p:nvGrpSpPr>
+        <p:cNvPr id="1" name=""/>
+        <p:cNvGrpSpPr/>
+        <p:nvPr/>
+      </p:nvGrpSpPr>
+      <p:grpSpPr>
+        <a:xfrm>
+          <a:off x="0" y="0"/>
+          <a:ext cx="0" cy="0"/>
+          <a:chOff x="0" y="0"/>
+          <a:chExt cx="0" cy="0"/>
+        </a:xfrm>
+      </p:grpSpPr>
+      <p:sp>
+        <p:nvSpPr>
+          <p:cNvPr id="2" name="Slide Image Placeholder 1"/>
+          <p:cNvSpPr>
+            <a:spLocks noGrp="1" noRot="1" noChangeAspect="1"/>
+          </p:cNvSpPr>
+          <p:nvPr>
+            <p:ph type="sldImg"/>
+          </p:nvPr>
+        </p:nvSpPr>
+        <p:spPr/>
+      </p:sp>
+      <p:sp>
+        <p:nvSpPr>
+          <p:cNvPr id="3" name="Notes Placeholder 2"/>
+          <p:cNvSpPr>
+            <a:spLocks noGrp="1"/>
+          </p:cNvSpPr>
+          <p:nvPr>
+            <p:ph type="body" idx="1"/>
+          </p:nvPr>
+        </p:nvSpPr>
+        <p:spPr/>
+        <p:txBody>
+          <a:bodyPr/>
+          <a:lstStyle/>
+          <a:p>
+            <a:r>
+              <a:rPr lang="en-US" dirty="0"/>
+              <a:t>Close on the ask. The tool is in use today on a single machine; the one thing standing between that and team-wide use is shared storage, which is specified and about a day of work — it belongs on the roadmap slide before this one.</a:t>
+            </a:r>
+            <a:endParaRPr lang="en-US" dirty="0"/>
+          </a:p>
+        </p:txBody>
+      </p:sp>
+      <p:sp>
+        <p:nvSpPr>
+          <p:cNvPr id="4" name="Slide Number Placeholder 3"/>
+          <p:cNvSpPr>
+            <a:spLocks noGrp="1"/>
+          </p:cNvSpPr>
+          <p:nvPr>
+            <p:ph type="sldNum" sz="quarter" idx="10"/>
+          </p:nvPr>
+        </p:nvSpPr>
+        <p:spPr/>
+        <p:txBody>
+          <a:bodyPr/>
+          <a:lstStyle/>
+          <a:p>
+            <a:fld id="{F7021451-1387-4CA6-816F-3879F97B5CBC}" type="slidenum">
+              <a:rPr lang="en-US"/>
+              <a:t>18</a:t>
             </a:fld>
             <a:endParaRPr lang="en-US"/>
           </a:p>
@@ -5801,6 +6068,2280 @@
     <p:bg>
       <p:bgPr>
         <a:solidFill>
+          <a:srgbClr val="FFFFFF"/>
+        </a:solidFill>
+      </p:bgPr>
+    </p:bg>
+    <p:spTree>
+      <p:nvGrpSpPr>
+        <p:cNvPr id="1" name=""/>
+        <p:cNvGrpSpPr/>
+        <p:nvPr/>
+      </p:nvGrpSpPr>
+      <p:grpSpPr>
+        <a:xfrm>
+          <a:off x="0" y="0"/>
+          <a:ext cx="0" cy="0"/>
+          <a:chOff x="0" y="0"/>
+          <a:chExt cx="0" cy="0"/>
+        </a:xfrm>
+      </p:grpSpPr>
+      <p:sp>
+        <p:nvSpPr>
+          <p:cNvPr id="2" name="Text 0"/>
+          <p:cNvSpPr/>
+          <p:nvPr/>
+        </p:nvSpPr>
+        <p:spPr>
+          <a:xfrm>
+            <a:off x="566928" y="347472"/>
+            <a:ext cx="8229600" cy="274320"/>
+          </a:xfrm>
+          <a:prstGeom prst="rect">
+            <a:avLst/>
+          </a:prstGeom>
+          <a:noFill/>
+          <a:ln/>
+        </p:spPr>
+        <p:txBody>
+          <a:bodyPr wrap="square" lIns="0" tIns="0" rIns="0" bIns="0" rtlCol="0" anchor="ctr"/>
+          <a:lstStyle/>
+          <a:p>
+            <a:pPr indent="0" marL="0">
+              <a:buNone/>
+            </a:pPr>
+            <a:r>
+              <a:rPr lang="en-US" sz="1200" b="1" spc="200" kern="0" dirty="0">
+                <a:solidFill>
+                  <a:srgbClr val="12AEBE"/>
+                </a:solidFill>
+                <a:latin typeface="Calibri" pitchFamily="34" charset="0"/>
+                <a:ea typeface="Calibri" pitchFamily="34" charset="-122"/>
+                <a:cs typeface="Calibri" pitchFamily="34" charset="-120"/>
+              </a:rPr>
+              <a:t>DESIGN</a:t>
+            </a:r>
+            <a:endParaRPr lang="en-US" sz="1200" dirty="0"/>
+          </a:p>
+        </p:txBody>
+      </p:sp>
+      <p:sp>
+        <p:nvSpPr>
+          <p:cNvPr id="3" name="Text 1"/>
+          <p:cNvSpPr/>
+          <p:nvPr/>
+        </p:nvSpPr>
+        <p:spPr>
+          <a:xfrm>
+            <a:off x="566928" y="713232"/>
+            <a:ext cx="10424160" cy="603504"/>
+          </a:xfrm>
+          <a:prstGeom prst="rect">
+            <a:avLst/>
+          </a:prstGeom>
+          <a:noFill/>
+          <a:ln/>
+        </p:spPr>
+        <p:txBody>
+          <a:bodyPr wrap="square" lIns="0" tIns="0" rIns="0" bIns="0" rtlCol="0" anchor="t"/>
+          <a:lstStyle/>
+          <a:p>
+            <a:pPr indent="0" marL="0">
+              <a:buNone/>
+            </a:pPr>
+            <a:r>
+              <a:rPr lang="en-US" sz="3200" b="1" dirty="0">
+                <a:solidFill>
+                  <a:srgbClr val="0A4B75"/>
+                </a:solidFill>
+                <a:latin typeface="Calibri" pitchFamily="34" charset="0"/>
+                <a:ea typeface="Calibri" pitchFamily="34" charset="-122"/>
+                <a:cs typeface="Calibri" pitchFamily="34" charset="-120"/>
+              </a:rPr>
+              <a:t>One mark, two grounds</a:t>
+            </a:r>
+            <a:endParaRPr lang="en-US" sz="3200" dirty="0"/>
+          </a:p>
+        </p:txBody>
+      </p:sp>
+      <p:pic>
+        <p:nvPicPr>
+          <p:cNvPr id="4" name="Image 0" descr="../deck/mark-light.png">    </p:cNvPr>
+          <p:cNvPicPr>
+            <a:picLocks noChangeAspect="1"/>
+          </p:cNvPicPr>
+          <p:nvPr/>
+        </p:nvPicPr>
+        <p:blipFill>
+          <a:blip r:embed="rId1"/>
+          <a:stretch>
+            <a:fillRect/>
+          </a:stretch>
+        </p:blipFill>
+        <p:spPr>
+          <a:xfrm>
+            <a:off x="11192256" y="402336"/>
+            <a:ext cx="402336" cy="402336"/>
+          </a:xfrm>
+          <a:prstGeom prst="rect">
+            <a:avLst/>
+          </a:prstGeom>
+        </p:spPr>
+      </p:pic>
+      <p:sp>
+        <p:nvSpPr>
+          <p:cNvPr id="5" name="Text 2"/>
+          <p:cNvSpPr/>
+          <p:nvPr/>
+        </p:nvSpPr>
+        <p:spPr>
+          <a:xfrm>
+            <a:off x="566928" y="1444752"/>
+            <a:ext cx="10515600" cy="640080"/>
+          </a:xfrm>
+          <a:prstGeom prst="rect">
+            <a:avLst/>
+          </a:prstGeom>
+          <a:noFill/>
+          <a:ln/>
+        </p:spPr>
+        <p:txBody>
+          <a:bodyPr wrap="square" lIns="0" tIns="0" rIns="0" bIns="0" rtlCol="0" anchor="ctr"/>
+          <a:lstStyle/>
+          <a:p>
+            <a:pPr indent="0" marL="0">
+              <a:lnSpc>
+                <a:spcPts val="2000"/>
+              </a:lnSpc>
+              <a:buNone/>
+            </a:pPr>
+            <a:r>
+              <a:rPr lang="en-US" sz="1400" dirty="0">
+                <a:solidFill>
+                  <a:srgbClr val="53606A"/>
+                </a:solidFill>
+                <a:latin typeface="Calibri" pitchFamily="34" charset="0"/>
+                <a:ea typeface="Calibri" pitchFamily="34" charset="-122"/>
+                <a:cs typeface="Calibri" pitchFamily="34" charset="-120"/>
+              </a:rPr>
+              <a:t>Three translucent panes on a rising diagonal — each stays visible through the last, and where two overlap the colour deepens rather than one hiding the other. The mark is drawn light on paper and dark on navy, and the interface follows the same pair.</a:t>
+            </a:r>
+            <a:endParaRPr lang="en-US" sz="1400" dirty="0"/>
+          </a:p>
+        </p:txBody>
+      </p:sp>
+      <p:sp>
+        <p:nvSpPr>
+          <p:cNvPr id="6" name="Shape 3"/>
+          <p:cNvSpPr/>
+          <p:nvPr/>
+        </p:nvSpPr>
+        <p:spPr>
+          <a:xfrm>
+            <a:off x="566928" y="2231136"/>
+            <a:ext cx="2606040" cy="1783080"/>
+          </a:xfrm>
+          <a:prstGeom prst="roundRect">
+            <a:avLst>
+              <a:gd name="adj" fmla="val 4103"/>
+            </a:avLst>
+          </a:prstGeom>
+          <a:solidFill>
+            <a:srgbClr val="F2F6F9"/>
+          </a:solidFill>
+          <a:ln w="12700">
+            <a:solidFill>
+              <a:srgbClr val="D9E4EC"/>
+            </a:solidFill>
+            <a:prstDash val="solid"/>
+          </a:ln>
+        </p:spPr>
+      </p:sp>
+      <p:pic>
+        <p:nvPicPr>
+          <p:cNvPr id="7" name="Image 1" descr="../deck/mark-light.png">    </p:cNvPr>
+          <p:cNvPicPr>
+            <a:picLocks noChangeAspect="1"/>
+          </p:cNvPicPr>
+          <p:nvPr/>
+        </p:nvPicPr>
+        <p:blipFill>
+          <a:blip r:embed="rId2"/>
+          <a:stretch>
+            <a:fillRect/>
+          </a:stretch>
+        </p:blipFill>
+        <p:spPr>
+          <a:xfrm>
+            <a:off x="1161288" y="2414016"/>
+            <a:ext cx="1417320" cy="1417320"/>
+          </a:xfrm>
+          <a:prstGeom prst="rect">
+            <a:avLst/>
+          </a:prstGeom>
+        </p:spPr>
+      </p:pic>
+      <p:sp>
+        <p:nvSpPr>
+          <p:cNvPr id="8" name="Text 4"/>
+          <p:cNvSpPr/>
+          <p:nvPr/>
+        </p:nvSpPr>
+        <p:spPr>
+          <a:xfrm>
+            <a:off x="566928" y="4096512"/>
+            <a:ext cx="2606040" cy="274320"/>
+          </a:xfrm>
+          <a:prstGeom prst="rect">
+            <a:avLst/>
+          </a:prstGeom>
+          <a:noFill/>
+          <a:ln/>
+        </p:spPr>
+        <p:txBody>
+          <a:bodyPr wrap="square" lIns="0" tIns="0" rIns="0" bIns="0" rtlCol="0" anchor="ctr"/>
+          <a:lstStyle/>
+          <a:p>
+            <a:pPr algn="ctr" indent="0" marL="0">
+              <a:buNone/>
+            </a:pPr>
+            <a:r>
+              <a:rPr lang="en-US" sz="1200" dirty="0">
+                <a:solidFill>
+                  <a:srgbClr val="53606A"/>
+                </a:solidFill>
+                <a:latin typeface="Calibri" pitchFamily="34" charset="0"/>
+                <a:ea typeface="Calibri" pitchFamily="34" charset="-122"/>
+                <a:cs typeface="Calibri" pitchFamily="34" charset="-120"/>
+              </a:rPr>
+              <a:t>The mark on paper</a:t>
+            </a:r>
+            <a:endParaRPr lang="en-US" sz="1200" dirty="0"/>
+          </a:p>
+        </p:txBody>
+      </p:sp>
+      <p:sp>
+        <p:nvSpPr>
+          <p:cNvPr id="9" name="Shape 5"/>
+          <p:cNvSpPr/>
+          <p:nvPr/>
+        </p:nvSpPr>
+        <p:spPr>
+          <a:xfrm>
+            <a:off x="3346704" y="2231136"/>
+            <a:ext cx="2606040" cy="1783080"/>
+          </a:xfrm>
+          <a:prstGeom prst="roundRect">
+            <a:avLst>
+              <a:gd name="adj" fmla="val 4103"/>
+            </a:avLst>
+          </a:prstGeom>
+          <a:solidFill>
+            <a:srgbClr val="073554"/>
+          </a:solidFill>
+          <a:ln w="12700">
+            <a:solidFill>
+              <a:srgbClr val="073554"/>
+            </a:solidFill>
+            <a:prstDash val="solid"/>
+          </a:ln>
+        </p:spPr>
+      </p:sp>
+      <p:pic>
+        <p:nvPicPr>
+          <p:cNvPr id="10" name="Image 2" descr="../deck/mark-dark.png">    </p:cNvPr>
+          <p:cNvPicPr>
+            <a:picLocks noChangeAspect="1"/>
+          </p:cNvPicPr>
+          <p:nvPr/>
+        </p:nvPicPr>
+        <p:blipFill>
+          <a:blip r:embed="rId3"/>
+          <a:stretch>
+            <a:fillRect/>
+          </a:stretch>
+        </p:blipFill>
+        <p:spPr>
+          <a:xfrm>
+            <a:off x="3941064" y="2414016"/>
+            <a:ext cx="1417320" cy="1417320"/>
+          </a:xfrm>
+          <a:prstGeom prst="rect">
+            <a:avLst/>
+          </a:prstGeom>
+        </p:spPr>
+      </p:pic>
+      <p:sp>
+        <p:nvSpPr>
+          <p:cNvPr id="11" name="Text 6"/>
+          <p:cNvSpPr/>
+          <p:nvPr/>
+        </p:nvSpPr>
+        <p:spPr>
+          <a:xfrm>
+            <a:off x="3346704" y="4096512"/>
+            <a:ext cx="2606040" cy="274320"/>
+          </a:xfrm>
+          <a:prstGeom prst="rect">
+            <a:avLst/>
+          </a:prstGeom>
+          <a:noFill/>
+          <a:ln/>
+        </p:spPr>
+        <p:txBody>
+          <a:bodyPr wrap="square" lIns="0" tIns="0" rIns="0" bIns="0" rtlCol="0" anchor="ctr"/>
+          <a:lstStyle/>
+          <a:p>
+            <a:pPr algn="ctr" indent="0" marL="0">
+              <a:buNone/>
+            </a:pPr>
+            <a:r>
+              <a:rPr lang="en-US" sz="1200" dirty="0">
+                <a:solidFill>
+                  <a:srgbClr val="53606A"/>
+                </a:solidFill>
+                <a:latin typeface="Calibri" pitchFamily="34" charset="0"/>
+                <a:ea typeface="Calibri" pitchFamily="34" charset="-122"/>
+                <a:cs typeface="Calibri" pitchFamily="34" charset="-120"/>
+              </a:rPr>
+              <a:t>The mark on navy</a:t>
+            </a:r>
+            <a:endParaRPr lang="en-US" sz="1200" dirty="0"/>
+          </a:p>
+        </p:txBody>
+      </p:sp>
+      <p:sp>
+        <p:nvSpPr>
+          <p:cNvPr id="12" name="Shape 7"/>
+          <p:cNvSpPr/>
+          <p:nvPr/>
+        </p:nvSpPr>
+        <p:spPr>
+          <a:xfrm>
+            <a:off x="6126480" y="2231136"/>
+            <a:ext cx="2606040" cy="1783080"/>
+          </a:xfrm>
+          <a:prstGeom prst="roundRect">
+            <a:avLst>
+              <a:gd name="adj" fmla="val 4103"/>
+            </a:avLst>
+          </a:prstGeom>
+          <a:solidFill>
+            <a:srgbClr val="F2F6F9"/>
+          </a:solidFill>
+          <a:ln w="12700">
+            <a:solidFill>
+              <a:srgbClr val="D9E4EC"/>
+            </a:solidFill>
+            <a:prstDash val="solid"/>
+          </a:ln>
+        </p:spPr>
+      </p:sp>
+      <p:pic>
+        <p:nvPicPr>
+          <p:cNvPr id="13" name="Image 3" descr="../deck/lockup.png">    </p:cNvPr>
+          <p:cNvPicPr>
+            <a:picLocks noChangeAspect="1"/>
+          </p:cNvPicPr>
+          <p:nvPr/>
+        </p:nvPicPr>
+        <p:blipFill>
+          <a:blip r:embed="rId4"/>
+          <a:stretch>
+            <a:fillRect/>
+          </a:stretch>
+        </p:blipFill>
+        <p:spPr>
+          <a:xfrm>
+            <a:off x="6905092" y="2414016"/>
+            <a:ext cx="1048817" cy="1417320"/>
+          </a:xfrm>
+          <a:prstGeom prst="rect">
+            <a:avLst/>
+          </a:prstGeom>
+        </p:spPr>
+      </p:pic>
+      <p:sp>
+        <p:nvSpPr>
+          <p:cNvPr id="14" name="Text 8"/>
+          <p:cNvSpPr/>
+          <p:nvPr/>
+        </p:nvSpPr>
+        <p:spPr>
+          <a:xfrm>
+            <a:off x="6126480" y="4096512"/>
+            <a:ext cx="2606040" cy="274320"/>
+          </a:xfrm>
+          <a:prstGeom prst="rect">
+            <a:avLst/>
+          </a:prstGeom>
+          <a:noFill/>
+          <a:ln/>
+        </p:spPr>
+        <p:txBody>
+          <a:bodyPr wrap="square" lIns="0" tIns="0" rIns="0" bIns="0" rtlCol="0" anchor="ctr"/>
+          <a:lstStyle/>
+          <a:p>
+            <a:pPr algn="ctr" indent="0" marL="0">
+              <a:buNone/>
+            </a:pPr>
+            <a:r>
+              <a:rPr lang="en-US" sz="1200" dirty="0">
+                <a:solidFill>
+                  <a:srgbClr val="53606A"/>
+                </a:solidFill>
+                <a:latin typeface="Calibri" pitchFamily="34" charset="0"/>
+                <a:ea typeface="Calibri" pitchFamily="34" charset="-122"/>
+                <a:cs typeface="Calibri" pitchFamily="34" charset="-120"/>
+              </a:rPr>
+              <a:t>Lockup, light theme</a:t>
+            </a:r>
+            <a:endParaRPr lang="en-US" sz="1200" dirty="0"/>
+          </a:p>
+        </p:txBody>
+      </p:sp>
+      <p:sp>
+        <p:nvSpPr>
+          <p:cNvPr id="15" name="Shape 9"/>
+          <p:cNvSpPr/>
+          <p:nvPr/>
+        </p:nvSpPr>
+        <p:spPr>
+          <a:xfrm>
+            <a:off x="8906256" y="2231136"/>
+            <a:ext cx="2606040" cy="1783080"/>
+          </a:xfrm>
+          <a:prstGeom prst="roundRect">
+            <a:avLst>
+              <a:gd name="adj" fmla="val 4103"/>
+            </a:avLst>
+          </a:prstGeom>
+          <a:solidFill>
+            <a:srgbClr val="0A1117"/>
+          </a:solidFill>
+          <a:ln w="12700">
+            <a:solidFill>
+              <a:srgbClr val="0A1117"/>
+            </a:solidFill>
+            <a:prstDash val="solid"/>
+          </a:ln>
+        </p:spPr>
+      </p:sp>
+      <p:pic>
+        <p:nvPicPr>
+          <p:cNvPr id="16" name="Image 4" descr="../deck/lockup-dk.png">    </p:cNvPr>
+          <p:cNvPicPr>
+            <a:picLocks noChangeAspect="1"/>
+          </p:cNvPicPr>
+          <p:nvPr/>
+        </p:nvPicPr>
+        <p:blipFill>
+          <a:blip r:embed="rId5"/>
+          <a:stretch>
+            <a:fillRect/>
+          </a:stretch>
+        </p:blipFill>
+        <p:spPr>
+          <a:xfrm>
+            <a:off x="9684868" y="2414016"/>
+            <a:ext cx="1048817" cy="1417320"/>
+          </a:xfrm>
+          <a:prstGeom prst="rect">
+            <a:avLst/>
+          </a:prstGeom>
+        </p:spPr>
+      </p:pic>
+      <p:sp>
+        <p:nvSpPr>
+          <p:cNvPr id="17" name="Text 10"/>
+          <p:cNvSpPr/>
+          <p:nvPr/>
+        </p:nvSpPr>
+        <p:spPr>
+          <a:xfrm>
+            <a:off x="8906256" y="4096512"/>
+            <a:ext cx="2606040" cy="274320"/>
+          </a:xfrm>
+          <a:prstGeom prst="rect">
+            <a:avLst/>
+          </a:prstGeom>
+          <a:noFill/>
+          <a:ln/>
+        </p:spPr>
+        <p:txBody>
+          <a:bodyPr wrap="square" lIns="0" tIns="0" rIns="0" bIns="0" rtlCol="0" anchor="ctr"/>
+          <a:lstStyle/>
+          <a:p>
+            <a:pPr algn="ctr" indent="0" marL="0">
+              <a:buNone/>
+            </a:pPr>
+            <a:r>
+              <a:rPr lang="en-US" sz="1200" dirty="0">
+                <a:solidFill>
+                  <a:srgbClr val="53606A"/>
+                </a:solidFill>
+                <a:latin typeface="Calibri" pitchFamily="34" charset="0"/>
+                <a:ea typeface="Calibri" pitchFamily="34" charset="-122"/>
+                <a:cs typeface="Calibri" pitchFamily="34" charset="-120"/>
+              </a:rPr>
+              <a:t>Lockup, dark theme</a:t>
+            </a:r>
+            <a:endParaRPr lang="en-US" sz="1200" dirty="0"/>
+          </a:p>
+        </p:txBody>
+      </p:sp>
+      <p:sp>
+        <p:nvSpPr>
+          <p:cNvPr id="18" name="Text 11"/>
+          <p:cNvSpPr/>
+          <p:nvPr/>
+        </p:nvSpPr>
+        <p:spPr>
+          <a:xfrm>
+            <a:off x="566928" y="4590288"/>
+            <a:ext cx="3657600" cy="256032"/>
+          </a:xfrm>
+          <a:prstGeom prst="rect">
+            <a:avLst/>
+          </a:prstGeom>
+          <a:noFill/>
+          <a:ln/>
+        </p:spPr>
+        <p:txBody>
+          <a:bodyPr wrap="square" lIns="0" tIns="0" rIns="0" bIns="0" rtlCol="0" anchor="ctr"/>
+          <a:lstStyle/>
+          <a:p>
+            <a:pPr indent="0" marL="0">
+              <a:buNone/>
+            </a:pPr>
+            <a:r>
+              <a:rPr lang="en-US" sz="1100" b="1" spc="140" kern="0" dirty="0">
+                <a:solidFill>
+                  <a:srgbClr val="12AEBE"/>
+                </a:solidFill>
+                <a:latin typeface="Calibri" pitchFamily="34" charset="0"/>
+                <a:ea typeface="Calibri" pitchFamily="34" charset="-122"/>
+                <a:cs typeface="Calibri" pitchFamily="34" charset="-120"/>
+              </a:rPr>
+              <a:t>THE PALETTE</a:t>
+            </a:r>
+            <a:endParaRPr lang="en-US" sz="1100" dirty="0"/>
+          </a:p>
+        </p:txBody>
+      </p:sp>
+      <p:sp>
+        <p:nvSpPr>
+          <p:cNvPr id="19" name="Shape 12"/>
+          <p:cNvSpPr/>
+          <p:nvPr/>
+        </p:nvSpPr>
+        <p:spPr>
+          <a:xfrm>
+            <a:off x="566928" y="4956048"/>
+            <a:ext cx="2011680" cy="457200"/>
+          </a:xfrm>
+          <a:prstGeom prst="roundRect">
+            <a:avLst>
+              <a:gd name="adj" fmla="val 10000"/>
+            </a:avLst>
+          </a:prstGeom>
+          <a:solidFill>
+            <a:srgbClr val="0A4B75"/>
+          </a:solidFill>
+          <a:ln w="12700">
+            <a:solidFill>
+              <a:srgbClr val="0A4B75"/>
+            </a:solidFill>
+            <a:prstDash val="solid"/>
+          </a:ln>
+        </p:spPr>
+      </p:sp>
+      <p:sp>
+        <p:nvSpPr>
+          <p:cNvPr id="20" name="Text 13"/>
+          <p:cNvSpPr/>
+          <p:nvPr/>
+        </p:nvSpPr>
+        <p:spPr>
+          <a:xfrm>
+            <a:off x="566928" y="5504688"/>
+            <a:ext cx="2011680" cy="237744"/>
+          </a:xfrm>
+          <a:prstGeom prst="rect">
+            <a:avLst/>
+          </a:prstGeom>
+          <a:noFill/>
+          <a:ln/>
+        </p:spPr>
+        <p:txBody>
+          <a:bodyPr wrap="square" lIns="0" tIns="0" rIns="0" bIns="0" rtlCol="0" anchor="ctr"/>
+          <a:lstStyle/>
+          <a:p>
+            <a:pPr indent="0" marL="0">
+              <a:buNone/>
+            </a:pPr>
+            <a:r>
+              <a:rPr lang="en-US" sz="1150" b="1" dirty="0">
+                <a:solidFill>
+                  <a:srgbClr val="0A4B75"/>
+                </a:solidFill>
+                <a:latin typeface="Calibri" pitchFamily="34" charset="0"/>
+                <a:ea typeface="Calibri" pitchFamily="34" charset="-122"/>
+                <a:cs typeface="Calibri" pitchFamily="34" charset="-120"/>
+              </a:rPr>
+              <a:t>Navy  ·  #0A4B75</a:t>
+            </a:r>
+            <a:endParaRPr lang="en-US" sz="1150" dirty="0"/>
+          </a:p>
+        </p:txBody>
+      </p:sp>
+      <p:sp>
+        <p:nvSpPr>
+          <p:cNvPr id="21" name="Text 14"/>
+          <p:cNvSpPr/>
+          <p:nvPr/>
+        </p:nvSpPr>
+        <p:spPr>
+          <a:xfrm>
+            <a:off x="566928" y="5724144"/>
+            <a:ext cx="2011680" cy="457200"/>
+          </a:xfrm>
+          <a:prstGeom prst="rect">
+            <a:avLst/>
+          </a:prstGeom>
+          <a:noFill/>
+          <a:ln/>
+        </p:spPr>
+        <p:txBody>
+          <a:bodyPr wrap="square" lIns="0" tIns="0" rIns="0" bIns="0" rtlCol="0" anchor="ctr"/>
+          <a:lstStyle/>
+          <a:p>
+            <a:pPr indent="0" marL="0">
+              <a:lnSpc>
+                <a:spcPts val="1400"/>
+              </a:lnSpc>
+              <a:buNone/>
+            </a:pPr>
+            <a:r>
+              <a:rPr lang="en-US" sz="1100" dirty="0">
+                <a:solidFill>
+                  <a:srgbClr val="53606A"/>
+                </a:solidFill>
+                <a:latin typeface="Calibri" pitchFamily="34" charset="0"/>
+                <a:ea typeface="Calibri" pitchFamily="34" charset="-122"/>
+                <a:cs typeface="Calibri" pitchFamily="34" charset="-120"/>
+              </a:rPr>
+              <a:t>Chrome, links, controls</a:t>
+            </a:r>
+            <a:endParaRPr lang="en-US" sz="1100" dirty="0"/>
+          </a:p>
+        </p:txBody>
+      </p:sp>
+      <p:sp>
+        <p:nvSpPr>
+          <p:cNvPr id="22" name="Shape 15"/>
+          <p:cNvSpPr/>
+          <p:nvPr/>
+        </p:nvSpPr>
+        <p:spPr>
+          <a:xfrm>
+            <a:off x="2779776" y="4956048"/>
+            <a:ext cx="2011680" cy="457200"/>
+          </a:xfrm>
+          <a:prstGeom prst="roundRect">
+            <a:avLst>
+              <a:gd name="adj" fmla="val 10000"/>
+            </a:avLst>
+          </a:prstGeom>
+          <a:solidFill>
+            <a:srgbClr val="073554"/>
+          </a:solidFill>
+          <a:ln w="12700">
+            <a:solidFill>
+              <a:srgbClr val="073554"/>
+            </a:solidFill>
+            <a:prstDash val="solid"/>
+          </a:ln>
+        </p:spPr>
+      </p:sp>
+      <p:sp>
+        <p:nvSpPr>
+          <p:cNvPr id="23" name="Text 16"/>
+          <p:cNvSpPr/>
+          <p:nvPr/>
+        </p:nvSpPr>
+        <p:spPr>
+          <a:xfrm>
+            <a:off x="2779776" y="5504688"/>
+            <a:ext cx="2011680" cy="237744"/>
+          </a:xfrm>
+          <a:prstGeom prst="rect">
+            <a:avLst/>
+          </a:prstGeom>
+          <a:noFill/>
+          <a:ln/>
+        </p:spPr>
+        <p:txBody>
+          <a:bodyPr wrap="square" lIns="0" tIns="0" rIns="0" bIns="0" rtlCol="0" anchor="ctr"/>
+          <a:lstStyle/>
+          <a:p>
+            <a:pPr indent="0" marL="0">
+              <a:buNone/>
+            </a:pPr>
+            <a:r>
+              <a:rPr lang="en-US" sz="1150" b="1" dirty="0">
+                <a:solidFill>
+                  <a:srgbClr val="0A4B75"/>
+                </a:solidFill>
+                <a:latin typeface="Calibri" pitchFamily="34" charset="0"/>
+                <a:ea typeface="Calibri" pitchFamily="34" charset="-122"/>
+                <a:cs typeface="Calibri" pitchFamily="34" charset="-120"/>
+              </a:rPr>
+              <a:t>Ink  ·  #073554</a:t>
+            </a:r>
+            <a:endParaRPr lang="en-US" sz="1150" dirty="0"/>
+          </a:p>
+        </p:txBody>
+      </p:sp>
+      <p:sp>
+        <p:nvSpPr>
+          <p:cNvPr id="24" name="Text 17"/>
+          <p:cNvSpPr/>
+          <p:nvPr/>
+        </p:nvSpPr>
+        <p:spPr>
+          <a:xfrm>
+            <a:off x="2779776" y="5724144"/>
+            <a:ext cx="2011680" cy="457200"/>
+          </a:xfrm>
+          <a:prstGeom prst="rect">
+            <a:avLst/>
+          </a:prstGeom>
+          <a:noFill/>
+          <a:ln/>
+        </p:spPr>
+        <p:txBody>
+          <a:bodyPr wrap="square" lIns="0" tIns="0" rIns="0" bIns="0" rtlCol="0" anchor="ctr"/>
+          <a:lstStyle/>
+          <a:p>
+            <a:pPr indent="0" marL="0">
+              <a:lnSpc>
+                <a:spcPts val="1400"/>
+              </a:lnSpc>
+              <a:buNone/>
+            </a:pPr>
+            <a:r>
+              <a:rPr lang="en-US" sz="1100" dirty="0">
+                <a:solidFill>
+                  <a:srgbClr val="53606A"/>
+                </a:solidFill>
+                <a:latin typeface="Calibri" pitchFamily="34" charset="0"/>
+                <a:ea typeface="Calibri" pitchFamily="34" charset="-122"/>
+                <a:cs typeface="Calibri" pitchFamily="34" charset="-120"/>
+              </a:rPr>
+              <a:t>The dark ground</a:t>
+            </a:r>
+            <a:endParaRPr lang="en-US" sz="1100" dirty="0"/>
+          </a:p>
+        </p:txBody>
+      </p:sp>
+      <p:sp>
+        <p:nvSpPr>
+          <p:cNvPr id="25" name="Shape 18"/>
+          <p:cNvSpPr/>
+          <p:nvPr/>
+        </p:nvSpPr>
+        <p:spPr>
+          <a:xfrm>
+            <a:off x="4992624" y="4956048"/>
+            <a:ext cx="2011680" cy="457200"/>
+          </a:xfrm>
+          <a:prstGeom prst="roundRect">
+            <a:avLst>
+              <a:gd name="adj" fmla="val 10000"/>
+            </a:avLst>
+          </a:prstGeom>
+          <a:solidFill>
+            <a:srgbClr val="12AEBE"/>
+          </a:solidFill>
+          <a:ln w="12700">
+            <a:solidFill>
+              <a:srgbClr val="12AEBE"/>
+            </a:solidFill>
+            <a:prstDash val="solid"/>
+          </a:ln>
+        </p:spPr>
+      </p:sp>
+      <p:sp>
+        <p:nvSpPr>
+          <p:cNvPr id="26" name="Text 19"/>
+          <p:cNvSpPr/>
+          <p:nvPr/>
+        </p:nvSpPr>
+        <p:spPr>
+          <a:xfrm>
+            <a:off x="4992624" y="5504688"/>
+            <a:ext cx="2011680" cy="237744"/>
+          </a:xfrm>
+          <a:prstGeom prst="rect">
+            <a:avLst/>
+          </a:prstGeom>
+          <a:noFill/>
+          <a:ln/>
+        </p:spPr>
+        <p:txBody>
+          <a:bodyPr wrap="square" lIns="0" tIns="0" rIns="0" bIns="0" rtlCol="0" anchor="ctr"/>
+          <a:lstStyle/>
+          <a:p>
+            <a:pPr indent="0" marL="0">
+              <a:buNone/>
+            </a:pPr>
+            <a:r>
+              <a:rPr lang="en-US" sz="1150" b="1" dirty="0">
+                <a:solidFill>
+                  <a:srgbClr val="0A4B75"/>
+                </a:solidFill>
+                <a:latin typeface="Calibri" pitchFamily="34" charset="0"/>
+                <a:ea typeface="Calibri" pitchFamily="34" charset="-122"/>
+                <a:cs typeface="Calibri" pitchFamily="34" charset="-120"/>
+              </a:rPr>
+              <a:t>Teal  ·  #12AEBE</a:t>
+            </a:r>
+            <a:endParaRPr lang="en-US" sz="1150" dirty="0"/>
+          </a:p>
+        </p:txBody>
+      </p:sp>
+      <p:sp>
+        <p:nvSpPr>
+          <p:cNvPr id="27" name="Text 20"/>
+          <p:cNvSpPr/>
+          <p:nvPr/>
+        </p:nvSpPr>
+        <p:spPr>
+          <a:xfrm>
+            <a:off x="4992624" y="5724144"/>
+            <a:ext cx="2011680" cy="457200"/>
+          </a:xfrm>
+          <a:prstGeom prst="rect">
+            <a:avLst/>
+          </a:prstGeom>
+          <a:noFill/>
+          <a:ln/>
+        </p:spPr>
+        <p:txBody>
+          <a:bodyPr wrap="square" lIns="0" tIns="0" rIns="0" bIns="0" rtlCol="0" anchor="ctr"/>
+          <a:lstStyle/>
+          <a:p>
+            <a:pPr indent="0" marL="0">
+              <a:lnSpc>
+                <a:spcPts val="1400"/>
+              </a:lnSpc>
+              <a:buNone/>
+            </a:pPr>
+            <a:r>
+              <a:rPr lang="en-US" sz="1100" dirty="0">
+                <a:solidFill>
+                  <a:srgbClr val="53606A"/>
+                </a:solidFill>
+                <a:latin typeface="Calibri" pitchFamily="34" charset="0"/>
+                <a:ea typeface="Calibri" pitchFamily="34" charset="-122"/>
+                <a:cs typeface="Calibri" pitchFamily="34" charset="-120"/>
+              </a:rPr>
+              <a:t>One highlight only</a:t>
+            </a:r>
+            <a:endParaRPr lang="en-US" sz="1100" dirty="0"/>
+          </a:p>
+        </p:txBody>
+      </p:sp>
+      <p:sp>
+        <p:nvSpPr>
+          <p:cNvPr id="28" name="Shape 21"/>
+          <p:cNvSpPr/>
+          <p:nvPr/>
+        </p:nvSpPr>
+        <p:spPr>
+          <a:xfrm>
+            <a:off x="7205472" y="4956048"/>
+            <a:ext cx="2011680" cy="457200"/>
+          </a:xfrm>
+          <a:prstGeom prst="roundRect">
+            <a:avLst>
+              <a:gd name="adj" fmla="val 10000"/>
+            </a:avLst>
+          </a:prstGeom>
+          <a:solidFill>
+            <a:srgbClr val="F2F6F9"/>
+          </a:solidFill>
+          <a:ln w="12700">
+            <a:solidFill>
+              <a:srgbClr val="D9E4EC"/>
+            </a:solidFill>
+            <a:prstDash val="solid"/>
+          </a:ln>
+        </p:spPr>
+      </p:sp>
+      <p:sp>
+        <p:nvSpPr>
+          <p:cNvPr id="29" name="Text 22"/>
+          <p:cNvSpPr/>
+          <p:nvPr/>
+        </p:nvSpPr>
+        <p:spPr>
+          <a:xfrm>
+            <a:off x="7205472" y="5504688"/>
+            <a:ext cx="2011680" cy="237744"/>
+          </a:xfrm>
+          <a:prstGeom prst="rect">
+            <a:avLst/>
+          </a:prstGeom>
+          <a:noFill/>
+          <a:ln/>
+        </p:spPr>
+        <p:txBody>
+          <a:bodyPr wrap="square" lIns="0" tIns="0" rIns="0" bIns="0" rtlCol="0" anchor="ctr"/>
+          <a:lstStyle/>
+          <a:p>
+            <a:pPr indent="0" marL="0">
+              <a:buNone/>
+            </a:pPr>
+            <a:r>
+              <a:rPr lang="en-US" sz="1150" b="1" dirty="0">
+                <a:solidFill>
+                  <a:srgbClr val="0A4B75"/>
+                </a:solidFill>
+                <a:latin typeface="Calibri" pitchFamily="34" charset="0"/>
+                <a:ea typeface="Calibri" pitchFamily="34" charset="-122"/>
+                <a:cs typeface="Calibri" pitchFamily="34" charset="-120"/>
+              </a:rPr>
+              <a:t>Paper  ·  #F2F6F9</a:t>
+            </a:r>
+            <a:endParaRPr lang="en-US" sz="1150" dirty="0"/>
+          </a:p>
+        </p:txBody>
+      </p:sp>
+      <p:sp>
+        <p:nvSpPr>
+          <p:cNvPr id="30" name="Text 23"/>
+          <p:cNvSpPr/>
+          <p:nvPr/>
+        </p:nvSpPr>
+        <p:spPr>
+          <a:xfrm>
+            <a:off x="7205472" y="5724144"/>
+            <a:ext cx="2011680" cy="457200"/>
+          </a:xfrm>
+          <a:prstGeom prst="rect">
+            <a:avLst/>
+          </a:prstGeom>
+          <a:noFill/>
+          <a:ln/>
+        </p:spPr>
+        <p:txBody>
+          <a:bodyPr wrap="square" lIns="0" tIns="0" rIns="0" bIns="0" rtlCol="0" anchor="ctr"/>
+          <a:lstStyle/>
+          <a:p>
+            <a:pPr indent="0" marL="0">
+              <a:lnSpc>
+                <a:spcPts val="1400"/>
+              </a:lnSpc>
+              <a:buNone/>
+            </a:pPr>
+            <a:r>
+              <a:rPr lang="en-US" sz="1100" dirty="0">
+                <a:solidFill>
+                  <a:srgbClr val="53606A"/>
+                </a:solidFill>
+                <a:latin typeface="Calibri" pitchFamily="34" charset="0"/>
+                <a:ea typeface="Calibri" pitchFamily="34" charset="-122"/>
+                <a:cs typeface="Calibri" pitchFamily="34" charset="-120"/>
+              </a:rPr>
+              <a:t>Cards and raised surfaces</a:t>
+            </a:r>
+            <a:endParaRPr lang="en-US" sz="1100" dirty="0"/>
+          </a:p>
+        </p:txBody>
+      </p:sp>
+      <p:sp>
+        <p:nvSpPr>
+          <p:cNvPr id="31" name="Shape 24"/>
+          <p:cNvSpPr/>
+          <p:nvPr/>
+        </p:nvSpPr>
+        <p:spPr>
+          <a:xfrm>
+            <a:off x="9418320" y="4956048"/>
+            <a:ext cx="2011680" cy="457200"/>
+          </a:xfrm>
+          <a:prstGeom prst="roundRect">
+            <a:avLst>
+              <a:gd name="adj" fmla="val 10000"/>
+            </a:avLst>
+          </a:prstGeom>
+          <a:solidFill>
+            <a:srgbClr val="BB3D48"/>
+          </a:solidFill>
+          <a:ln w="12700">
+            <a:solidFill>
+              <a:srgbClr val="BB3D48"/>
+            </a:solidFill>
+            <a:prstDash val="solid"/>
+          </a:ln>
+        </p:spPr>
+      </p:sp>
+      <p:sp>
+        <p:nvSpPr>
+          <p:cNvPr id="32" name="Text 25"/>
+          <p:cNvSpPr/>
+          <p:nvPr/>
+        </p:nvSpPr>
+        <p:spPr>
+          <a:xfrm>
+            <a:off x="9418320" y="5504688"/>
+            <a:ext cx="2011680" cy="237744"/>
+          </a:xfrm>
+          <a:prstGeom prst="rect">
+            <a:avLst/>
+          </a:prstGeom>
+          <a:noFill/>
+          <a:ln/>
+        </p:spPr>
+        <p:txBody>
+          <a:bodyPr wrap="square" lIns="0" tIns="0" rIns="0" bIns="0" rtlCol="0" anchor="ctr"/>
+          <a:lstStyle/>
+          <a:p>
+            <a:pPr indent="0" marL="0">
+              <a:buNone/>
+            </a:pPr>
+            <a:r>
+              <a:rPr lang="en-US" sz="1150" b="1" dirty="0">
+                <a:solidFill>
+                  <a:srgbClr val="0A4B75"/>
+                </a:solidFill>
+                <a:latin typeface="Calibri" pitchFamily="34" charset="0"/>
+                <a:ea typeface="Calibri" pitchFamily="34" charset="-122"/>
+                <a:cs typeface="Calibri" pitchFamily="34" charset="-120"/>
+              </a:rPr>
+              <a:t>Alert  ·  #BB3D48</a:t>
+            </a:r>
+            <a:endParaRPr lang="en-US" sz="1150" dirty="0"/>
+          </a:p>
+        </p:txBody>
+      </p:sp>
+      <p:sp>
+        <p:nvSpPr>
+          <p:cNvPr id="33" name="Text 26"/>
+          <p:cNvSpPr/>
+          <p:nvPr/>
+        </p:nvSpPr>
+        <p:spPr>
+          <a:xfrm>
+            <a:off x="9418320" y="5724144"/>
+            <a:ext cx="2011680" cy="457200"/>
+          </a:xfrm>
+          <a:prstGeom prst="rect">
+            <a:avLst/>
+          </a:prstGeom>
+          <a:noFill/>
+          <a:ln/>
+        </p:spPr>
+        <p:txBody>
+          <a:bodyPr wrap="square" lIns="0" tIns="0" rIns="0" bIns="0" rtlCol="0" anchor="ctr"/>
+          <a:lstStyle/>
+          <a:p>
+            <a:pPr indent="0" marL="0">
+              <a:lnSpc>
+                <a:spcPts val="1400"/>
+              </a:lnSpc>
+              <a:buNone/>
+            </a:pPr>
+            <a:r>
+              <a:rPr lang="en-US" sz="1100" dirty="0">
+                <a:solidFill>
+                  <a:srgbClr val="53606A"/>
+                </a:solidFill>
+                <a:latin typeface="Calibri" pitchFamily="34" charset="0"/>
+                <a:ea typeface="Calibri" pitchFamily="34" charset="-122"/>
+                <a:cs typeface="Calibri" pitchFamily="34" charset="-120"/>
+              </a:rPr>
+              <a:t>At risk, and nothing else</a:t>
+            </a:r>
+            <a:endParaRPr lang="en-US" sz="1100" dirty="0"/>
+          </a:p>
+        </p:txBody>
+      </p:sp>
+      <p:sp>
+        <p:nvSpPr>
+          <p:cNvPr id="34" name="Text 27"/>
+          <p:cNvSpPr/>
+          <p:nvPr/>
+        </p:nvSpPr>
+        <p:spPr>
+          <a:xfrm>
+            <a:off x="566928" y="6327648"/>
+            <a:ext cx="10515600" cy="274320"/>
+          </a:xfrm>
+          <a:prstGeom prst="rect">
+            <a:avLst/>
+          </a:prstGeom>
+          <a:noFill/>
+          <a:ln/>
+        </p:spPr>
+        <p:txBody>
+          <a:bodyPr wrap="square" lIns="0" tIns="0" rIns="0" bIns="0" rtlCol="0" anchor="ctr"/>
+          <a:lstStyle/>
+          <a:p>
+            <a:pPr indent="0" marL="0">
+              <a:buNone/>
+            </a:pPr>
+            <a:r>
+              <a:rPr lang="en-US" sz="1250" i="1" dirty="0">
+                <a:solidFill>
+                  <a:srgbClr val="0A4B75"/>
+                </a:solidFill>
+                <a:latin typeface="Calibri" pitchFamily="34" charset="0"/>
+                <a:ea typeface="Calibri" pitchFamily="34" charset="-122"/>
+                <a:cs typeface="Calibri" pitchFamily="34" charset="-120"/>
+              </a:rPr>
+              <a:t>Set throughout in Poppins — geometric, wide, and legible down to the smallest label on a chart.</a:t>
+            </a:r>
+            <a:endParaRPr lang="en-US" sz="1250" dirty="0"/>
+          </a:p>
+        </p:txBody>
+      </p:sp>
+    </p:spTree>
+  </p:cSld>
+  <p:clrMapOvr>
+    <a:masterClrMapping/>
+  </p:clrMapOvr>
+</p:sld>
+</file>
+
+<file path=ppt/slides/slide16.xml><?xml version="1.0" encoding="utf-8"?>
+<p:sld xmlns:a="http://schemas.openxmlformats.org/drawingml/2006/main" xmlns:r="http://schemas.openxmlformats.org/officeDocument/2006/relationships" xmlns:p="http://schemas.openxmlformats.org/presentationml/2006/main">
+  <p:cSld name="Slide 16">
+    <p:bg>
+      <p:bgPr>
+        <a:solidFill>
+          <a:srgbClr val="FFFFFF"/>
+        </a:solidFill>
+      </p:bgPr>
+    </p:bg>
+    <p:spTree>
+      <p:nvGrpSpPr>
+        <p:cNvPr id="1" name=""/>
+        <p:cNvGrpSpPr/>
+        <p:nvPr/>
+      </p:nvGrpSpPr>
+      <p:grpSpPr>
+        <a:xfrm>
+          <a:off x="0" y="0"/>
+          <a:ext cx="0" cy="0"/>
+          <a:chOff x="0" y="0"/>
+          <a:chExt cx="0" cy="0"/>
+        </a:xfrm>
+      </p:grpSpPr>
+      <p:sp>
+        <p:nvSpPr>
+          <p:cNvPr id="2" name="Text 0"/>
+          <p:cNvSpPr/>
+          <p:nvPr/>
+        </p:nvSpPr>
+        <p:spPr>
+          <a:xfrm>
+            <a:off x="566928" y="347472"/>
+            <a:ext cx="8229600" cy="274320"/>
+          </a:xfrm>
+          <a:prstGeom prst="rect">
+            <a:avLst/>
+          </a:prstGeom>
+          <a:noFill/>
+          <a:ln/>
+        </p:spPr>
+        <p:txBody>
+          <a:bodyPr wrap="square" lIns="0" tIns="0" rIns="0" bIns="0" rtlCol="0" anchor="ctr"/>
+          <a:lstStyle/>
+          <a:p>
+            <a:pPr indent="0" marL="0">
+              <a:buNone/>
+            </a:pPr>
+            <a:r>
+              <a:rPr lang="en-US" sz="1200" b="1" spc="200" kern="0" dirty="0">
+                <a:solidFill>
+                  <a:srgbClr val="12AEBE"/>
+                </a:solidFill>
+                <a:latin typeface="Calibri" pitchFamily="34" charset="0"/>
+                <a:ea typeface="Calibri" pitchFamily="34" charset="-122"/>
+                <a:cs typeface="Calibri" pitchFamily="34" charset="-120"/>
+              </a:rPr>
+              <a:t>DESIGN</a:t>
+            </a:r>
+            <a:endParaRPr lang="en-US" sz="1200" dirty="0"/>
+          </a:p>
+        </p:txBody>
+      </p:sp>
+      <p:sp>
+        <p:nvSpPr>
+          <p:cNvPr id="3" name="Text 1"/>
+          <p:cNvSpPr/>
+          <p:nvPr/>
+        </p:nvSpPr>
+        <p:spPr>
+          <a:xfrm>
+            <a:off x="566928" y="713232"/>
+            <a:ext cx="10424160" cy="603504"/>
+          </a:xfrm>
+          <a:prstGeom prst="rect">
+            <a:avLst/>
+          </a:prstGeom>
+          <a:noFill/>
+          <a:ln/>
+        </p:spPr>
+        <p:txBody>
+          <a:bodyPr wrap="square" lIns="0" tIns="0" rIns="0" bIns="0" rtlCol="0" anchor="t"/>
+          <a:lstStyle/>
+          <a:p>
+            <a:pPr indent="0" marL="0">
+              <a:buNone/>
+            </a:pPr>
+            <a:r>
+              <a:rPr lang="en-US" sz="3200" b="1" dirty="0">
+                <a:solidFill>
+                  <a:srgbClr val="0A4B75"/>
+                </a:solidFill>
+                <a:latin typeface="Calibri" pitchFamily="34" charset="0"/>
+                <a:ea typeface="Calibri" pitchFamily="34" charset="-122"/>
+                <a:cs typeface="Calibri" pitchFamily="34" charset="-120"/>
+              </a:rPr>
+              <a:t>The same screen, either way up</a:t>
+            </a:r>
+            <a:endParaRPr lang="en-US" sz="3200" dirty="0"/>
+          </a:p>
+        </p:txBody>
+      </p:sp>
+      <p:pic>
+        <p:nvPicPr>
+          <p:cNvPr id="4" name="Image 0" descr="../deck/mark-light.png">    </p:cNvPr>
+          <p:cNvPicPr>
+            <a:picLocks noChangeAspect="1"/>
+          </p:cNvPicPr>
+          <p:nvPr/>
+        </p:nvPicPr>
+        <p:blipFill>
+          <a:blip r:embed="rId1"/>
+          <a:stretch>
+            <a:fillRect/>
+          </a:stretch>
+        </p:blipFill>
+        <p:spPr>
+          <a:xfrm>
+            <a:off x="11192256" y="402336"/>
+            <a:ext cx="402336" cy="402336"/>
+          </a:xfrm>
+          <a:prstGeom prst="rect">
+            <a:avLst/>
+          </a:prstGeom>
+        </p:spPr>
+      </p:pic>
+      <p:sp>
+        <p:nvSpPr>
+          <p:cNvPr id="5" name="Text 2"/>
+          <p:cNvSpPr/>
+          <p:nvPr/>
+        </p:nvSpPr>
+        <p:spPr>
+          <a:xfrm>
+            <a:off x="566928" y="1444752"/>
+            <a:ext cx="10515600" cy="640080"/>
+          </a:xfrm>
+          <a:prstGeom prst="rect">
+            <a:avLst/>
+          </a:prstGeom>
+          <a:noFill/>
+          <a:ln/>
+        </p:spPr>
+        <p:txBody>
+          <a:bodyPr wrap="square" lIns="0" tIns="0" rIns="0" bIns="0" rtlCol="0" anchor="ctr"/>
+          <a:lstStyle/>
+          <a:p>
+            <a:pPr indent="0" marL="0">
+              <a:lnSpc>
+                <a:spcPts val="2000"/>
+              </a:lnSpc>
+              <a:buNone/>
+            </a:pPr>
+            <a:r>
+              <a:rPr lang="en-US" sz="1400" dirty="0">
+                <a:solidFill>
+                  <a:srgbClr val="53606A"/>
+                </a:solidFill>
+                <a:latin typeface="Calibri" pitchFamily="34" charset="0"/>
+                <a:ea typeface="Calibri" pitchFamily="34" charset="-122"/>
+                <a:cs typeface="Calibri" pitchFamily="34" charset="-120"/>
+              </a:rPr>
+              <a:t>One theme switch in the corner of the menu. Every colour on every screen is a named role rather than a fixed value, so the whole interface turns over at once — and every figure was checked for contrast afterwards, on each screen and in each panel.</a:t>
+            </a:r>
+            <a:endParaRPr lang="en-US" sz="1400" dirty="0"/>
+          </a:p>
+        </p:txBody>
+      </p:sp>
+      <p:sp>
+        <p:nvSpPr>
+          <p:cNvPr id="6" name="Shape 3"/>
+          <p:cNvSpPr/>
+          <p:nvPr/>
+        </p:nvSpPr>
+        <p:spPr>
+          <a:xfrm>
+            <a:off x="475488" y="2194560"/>
+            <a:ext cx="5504688" cy="3511296"/>
+          </a:xfrm>
+          <a:prstGeom prst="roundRect">
+            <a:avLst>
+              <a:gd name="adj" fmla="val 1563"/>
+            </a:avLst>
+          </a:prstGeom>
+          <a:solidFill>
+            <a:srgbClr val="F2F6F9"/>
+          </a:solidFill>
+          <a:ln w="12700">
+            <a:solidFill>
+              <a:srgbClr val="D9E4EC"/>
+            </a:solidFill>
+            <a:prstDash val="solid"/>
+          </a:ln>
+          <a:effectLst>
+            <a:outerShdw sx="100000" sy="100000" kx="0" ky="0" algn="bl" rotWithShape="0" blurRad="177800" dist="38100" dir="5400000">
+              <a:srgbClr val="0A2740">
+                <a:alpha val="22000"/>
+              </a:srgbClr>
+            </a:outerShdw>
+          </a:effectLst>
+        </p:spPr>
+      </p:sp>
+      <p:pic>
+        <p:nvPicPr>
+          <p:cNvPr id="7" name="Image 1" descr="../deck/portfolio-screen.png">    </p:cNvPr>
+          <p:cNvPicPr>
+            <a:picLocks noChangeAspect="1"/>
+          </p:cNvPicPr>
+          <p:nvPr/>
+        </p:nvPicPr>
+        <p:blipFill>
+          <a:blip r:embed="rId2"/>
+          <a:srcRect l="0" r="0" t="0" b="0"/>
+          <a:stretch/>
+        </p:blipFill>
+        <p:spPr>
+          <a:xfrm>
+            <a:off x="566928" y="2286000"/>
+            <a:ext cx="5321808" cy="3328416"/>
+          </a:xfrm>
+          <a:prstGeom prst="rect">
+            <a:avLst/>
+          </a:prstGeom>
+        </p:spPr>
+      </p:pic>
+      <p:sp>
+        <p:nvSpPr>
+          <p:cNvPr id="8" name="Text 4"/>
+          <p:cNvSpPr/>
+          <p:nvPr/>
+        </p:nvSpPr>
+        <p:spPr>
+          <a:xfrm>
+            <a:off x="566928" y="5724144"/>
+            <a:ext cx="5321808" cy="274320"/>
+          </a:xfrm>
+          <a:prstGeom prst="rect">
+            <a:avLst/>
+          </a:prstGeom>
+          <a:noFill/>
+          <a:ln/>
+        </p:spPr>
+        <p:txBody>
+          <a:bodyPr wrap="square" lIns="0" tIns="0" rIns="0" bIns="0" rtlCol="0" anchor="ctr"/>
+          <a:lstStyle/>
+          <a:p>
+            <a:pPr algn="ctr" indent="0" marL="0">
+              <a:buNone/>
+            </a:pPr>
+            <a:r>
+              <a:rPr lang="en-US" sz="1200" b="1" dirty="0">
+                <a:solidFill>
+                  <a:srgbClr val="53606A"/>
+                </a:solidFill>
+                <a:latin typeface="Calibri" pitchFamily="34" charset="0"/>
+                <a:ea typeface="Calibri" pitchFamily="34" charset="-122"/>
+                <a:cs typeface="Calibri" pitchFamily="34" charset="-120"/>
+              </a:rPr>
+              <a:t>Portfolio, light</a:t>
+            </a:r>
+            <a:endParaRPr lang="en-US" sz="1200" dirty="0"/>
+          </a:p>
+        </p:txBody>
+      </p:sp>
+      <p:sp>
+        <p:nvSpPr>
+          <p:cNvPr id="9" name="Shape 5"/>
+          <p:cNvSpPr/>
+          <p:nvPr/>
+        </p:nvSpPr>
+        <p:spPr>
+          <a:xfrm>
+            <a:off x="6181344" y="2194560"/>
+            <a:ext cx="5504688" cy="3511296"/>
+          </a:xfrm>
+          <a:prstGeom prst="roundRect">
+            <a:avLst>
+              <a:gd name="adj" fmla="val 1563"/>
+            </a:avLst>
+          </a:prstGeom>
+          <a:solidFill>
+            <a:srgbClr val="F2F6F9"/>
+          </a:solidFill>
+          <a:ln w="12700">
+            <a:solidFill>
+              <a:srgbClr val="D9E4EC"/>
+            </a:solidFill>
+            <a:prstDash val="solid"/>
+          </a:ln>
+          <a:effectLst>
+            <a:outerShdw sx="100000" sy="100000" kx="0" ky="0" algn="bl" rotWithShape="0" blurRad="177800" dist="38100" dir="5400000">
+              <a:srgbClr val="0A2740">
+                <a:alpha val="22000"/>
+              </a:srgbClr>
+            </a:outerShdw>
+          </a:effectLst>
+        </p:spPr>
+      </p:sp>
+      <p:pic>
+        <p:nvPicPr>
+          <p:cNvPr id="10" name="Image 2" descr="../deck/portfolio-screen-dk.png">    </p:cNvPr>
+          <p:cNvPicPr>
+            <a:picLocks noChangeAspect="1"/>
+          </p:cNvPicPr>
+          <p:nvPr/>
+        </p:nvPicPr>
+        <p:blipFill>
+          <a:blip r:embed="rId3"/>
+          <a:srcRect l="0" r="0" t="0" b="0"/>
+          <a:stretch/>
+        </p:blipFill>
+        <p:spPr>
+          <a:xfrm>
+            <a:off x="6272784" y="2286000"/>
+            <a:ext cx="5321808" cy="3328416"/>
+          </a:xfrm>
+          <a:prstGeom prst="rect">
+            <a:avLst/>
+          </a:prstGeom>
+        </p:spPr>
+      </p:pic>
+      <p:sp>
+        <p:nvSpPr>
+          <p:cNvPr id="11" name="Text 6"/>
+          <p:cNvSpPr/>
+          <p:nvPr/>
+        </p:nvSpPr>
+        <p:spPr>
+          <a:xfrm>
+            <a:off x="6272784" y="5724144"/>
+            <a:ext cx="5321808" cy="274320"/>
+          </a:xfrm>
+          <a:prstGeom prst="rect">
+            <a:avLst/>
+          </a:prstGeom>
+          <a:noFill/>
+          <a:ln/>
+        </p:spPr>
+        <p:txBody>
+          <a:bodyPr wrap="square" lIns="0" tIns="0" rIns="0" bIns="0" rtlCol="0" anchor="ctr"/>
+          <a:lstStyle/>
+          <a:p>
+            <a:pPr algn="ctr" indent="0" marL="0">
+              <a:buNone/>
+            </a:pPr>
+            <a:r>
+              <a:rPr lang="en-US" sz="1200" b="1" dirty="0">
+                <a:solidFill>
+                  <a:srgbClr val="53606A"/>
+                </a:solidFill>
+                <a:latin typeface="Calibri" pitchFamily="34" charset="0"/>
+                <a:ea typeface="Calibri" pitchFamily="34" charset="-122"/>
+                <a:cs typeface="Calibri" pitchFamily="34" charset="-120"/>
+              </a:rPr>
+              <a:t>Portfolio, dark</a:t>
+            </a:r>
+            <a:endParaRPr lang="en-US" sz="1200" dirty="0"/>
+          </a:p>
+        </p:txBody>
+      </p:sp>
+      <p:sp>
+        <p:nvSpPr>
+          <p:cNvPr id="12" name="Text 7"/>
+          <p:cNvSpPr/>
+          <p:nvPr/>
+        </p:nvSpPr>
+        <p:spPr>
+          <a:xfrm>
+            <a:off x="566928" y="6163056"/>
+            <a:ext cx="10515600" cy="274320"/>
+          </a:xfrm>
+          <a:prstGeom prst="rect">
+            <a:avLst/>
+          </a:prstGeom>
+          <a:noFill/>
+          <a:ln/>
+        </p:spPr>
+        <p:txBody>
+          <a:bodyPr wrap="square" lIns="0" tIns="0" rIns="0" bIns="0" rtlCol="0" anchor="ctr"/>
+          <a:lstStyle/>
+          <a:p>
+            <a:pPr indent="0" marL="0">
+              <a:buNone/>
+            </a:pPr>
+            <a:r>
+              <a:rPr lang="en-US" sz="1250" i="1" dirty="0">
+                <a:solidFill>
+                  <a:srgbClr val="0A4B75"/>
+                </a:solidFill>
+                <a:latin typeface="Calibri" pitchFamily="34" charset="0"/>
+                <a:ea typeface="Calibri" pitchFamily="34" charset="-122"/>
+                <a:cs typeface="Calibri" pitchFamily="34" charset="-120"/>
+              </a:rPr>
+              <a:t>3,670 pieces of text measured against the ground they are painted on — none below the readable minimum.</a:t>
+            </a:r>
+            <a:endParaRPr lang="en-US" sz="1250" dirty="0"/>
+          </a:p>
+        </p:txBody>
+      </p:sp>
+    </p:spTree>
+  </p:cSld>
+  <p:clrMapOvr>
+    <a:masterClrMapping/>
+  </p:clrMapOvr>
+</p:sld>
+</file>
+
+<file path=ppt/slides/slide17.xml><?xml version="1.0" encoding="utf-8"?>
+<p:sld xmlns:a="http://schemas.openxmlformats.org/drawingml/2006/main" xmlns:r="http://schemas.openxmlformats.org/officeDocument/2006/relationships" xmlns:p="http://schemas.openxmlformats.org/presentationml/2006/main">
+  <p:cSld name="Slide 17">
+    <p:bg>
+      <p:bgPr>
+        <a:solidFill>
+          <a:srgbClr val="FFFFFF"/>
+        </a:solidFill>
+      </p:bgPr>
+    </p:bg>
+    <p:spTree>
+      <p:nvGrpSpPr>
+        <p:cNvPr id="1" name=""/>
+        <p:cNvGrpSpPr/>
+        <p:nvPr/>
+      </p:nvGrpSpPr>
+      <p:grpSpPr>
+        <a:xfrm>
+          <a:off x="0" y="0"/>
+          <a:ext cx="0" cy="0"/>
+          <a:chOff x="0" y="0"/>
+          <a:chExt cx="0" cy="0"/>
+        </a:xfrm>
+      </p:grpSpPr>
+      <p:sp>
+        <p:nvSpPr>
+          <p:cNvPr id="2" name="Text 0"/>
+          <p:cNvSpPr/>
+          <p:nvPr/>
+        </p:nvSpPr>
+        <p:spPr>
+          <a:xfrm>
+            <a:off x="566928" y="347472"/>
+            <a:ext cx="8229600" cy="274320"/>
+          </a:xfrm>
+          <a:prstGeom prst="rect">
+            <a:avLst/>
+          </a:prstGeom>
+          <a:noFill/>
+          <a:ln/>
+        </p:spPr>
+        <p:txBody>
+          <a:bodyPr wrap="square" lIns="0" tIns="0" rIns="0" bIns="0" rtlCol="0" anchor="ctr"/>
+          <a:lstStyle/>
+          <a:p>
+            <a:pPr indent="0" marL="0">
+              <a:buNone/>
+            </a:pPr>
+            <a:r>
+              <a:rPr lang="en-US" sz="1200" b="1" spc="200" kern="0" dirty="0">
+                <a:solidFill>
+                  <a:srgbClr val="12AEBE"/>
+                </a:solidFill>
+                <a:latin typeface="Calibri" pitchFamily="34" charset="0"/>
+                <a:ea typeface="Calibri" pitchFamily="34" charset="-122"/>
+                <a:cs typeface="Calibri" pitchFamily="34" charset="-120"/>
+              </a:rPr>
+              <a:t>ROADMAP</a:t>
+            </a:r>
+            <a:endParaRPr lang="en-US" sz="1200" dirty="0"/>
+          </a:p>
+        </p:txBody>
+      </p:sp>
+      <p:sp>
+        <p:nvSpPr>
+          <p:cNvPr id="3" name="Text 1"/>
+          <p:cNvSpPr/>
+          <p:nvPr/>
+        </p:nvSpPr>
+        <p:spPr>
+          <a:xfrm>
+            <a:off x="566928" y="713232"/>
+            <a:ext cx="10424160" cy="603504"/>
+          </a:xfrm>
+          <a:prstGeom prst="rect">
+            <a:avLst/>
+          </a:prstGeom>
+          <a:noFill/>
+          <a:ln/>
+        </p:spPr>
+        <p:txBody>
+          <a:bodyPr wrap="square" lIns="0" tIns="0" rIns="0" bIns="0" rtlCol="0" anchor="t"/>
+          <a:lstStyle/>
+          <a:p>
+            <a:pPr indent="0" marL="0">
+              <a:buNone/>
+            </a:pPr>
+            <a:r>
+              <a:rPr lang="en-US" sz="3200" b="1" dirty="0">
+                <a:solidFill>
+                  <a:srgbClr val="0A4B75"/>
+                </a:solidFill>
+                <a:latin typeface="Calibri" pitchFamily="34" charset="0"/>
+                <a:ea typeface="Calibri" pitchFamily="34" charset="-122"/>
+                <a:cs typeface="Calibri" pitchFamily="34" charset="-120"/>
+              </a:rPr>
+              <a:t>What’s next</a:t>
+            </a:r>
+            <a:endParaRPr lang="en-US" sz="3200" dirty="0"/>
+          </a:p>
+        </p:txBody>
+      </p:sp>
+      <p:pic>
+        <p:nvPicPr>
+          <p:cNvPr id="4" name="Image 0" descr="../deck/mark-light.png">    </p:cNvPr>
+          <p:cNvPicPr>
+            <a:picLocks noChangeAspect="1"/>
+          </p:cNvPicPr>
+          <p:nvPr/>
+        </p:nvPicPr>
+        <p:blipFill>
+          <a:blip r:embed="rId1"/>
+          <a:stretch>
+            <a:fillRect/>
+          </a:stretch>
+        </p:blipFill>
+        <p:spPr>
+          <a:xfrm>
+            <a:off x="11192256" y="402336"/>
+            <a:ext cx="402336" cy="402336"/>
+          </a:xfrm>
+          <a:prstGeom prst="rect">
+            <a:avLst/>
+          </a:prstGeom>
+        </p:spPr>
+      </p:pic>
+      <p:sp>
+        <p:nvSpPr>
+          <p:cNvPr id="5" name="Text 2"/>
+          <p:cNvSpPr/>
+          <p:nvPr/>
+        </p:nvSpPr>
+        <p:spPr>
+          <a:xfrm>
+            <a:off x="566928" y="1444752"/>
+            <a:ext cx="10515600" cy="365760"/>
+          </a:xfrm>
+          <a:prstGeom prst="rect">
+            <a:avLst/>
+          </a:prstGeom>
+          <a:noFill/>
+          <a:ln/>
+        </p:spPr>
+        <p:txBody>
+          <a:bodyPr wrap="square" lIns="0" tIns="0" rIns="0" bIns="0" rtlCol="0" anchor="ctr"/>
+          <a:lstStyle/>
+          <a:p>
+            <a:pPr indent="0" marL="0">
+              <a:buNone/>
+            </a:pPr>
+            <a:r>
+              <a:rPr lang="en-US" sz="1500" dirty="0">
+                <a:solidFill>
+                  <a:srgbClr val="53606A"/>
+                </a:solidFill>
+                <a:latin typeface="Calibri" pitchFamily="34" charset="0"/>
+                <a:ea typeface="Calibri" pitchFamily="34" charset="-122"/>
+                <a:cs typeface="Calibri" pitchFamily="34" charset="-120"/>
+              </a:rPr>
+              <a:t>Where this goes from here.</a:t>
+            </a:r>
+            <a:endParaRPr lang="en-US" sz="1500" dirty="0"/>
+          </a:p>
+        </p:txBody>
+      </p:sp>
+      <p:sp>
+        <p:nvSpPr>
+          <p:cNvPr id="6" name="Shape 3"/>
+          <p:cNvSpPr/>
+          <p:nvPr/>
+        </p:nvSpPr>
+        <p:spPr>
+          <a:xfrm>
+            <a:off x="566928" y="2157984"/>
+            <a:ext cx="3383280" cy="3200400"/>
+          </a:xfrm>
+          <a:prstGeom prst="roundRect">
+            <a:avLst>
+              <a:gd name="adj" fmla="val 2286"/>
+            </a:avLst>
+          </a:prstGeom>
+          <a:solidFill>
+            <a:srgbClr val="F2F6F9"/>
+          </a:solidFill>
+          <a:ln w="12700">
+            <a:solidFill>
+              <a:srgbClr val="DCE7EF"/>
+            </a:solidFill>
+            <a:prstDash val="solid"/>
+          </a:ln>
+        </p:spPr>
+      </p:sp>
+      <p:sp>
+        <p:nvSpPr>
+          <p:cNvPr id="7" name="Shape 4"/>
+          <p:cNvSpPr/>
+          <p:nvPr/>
+        </p:nvSpPr>
+        <p:spPr>
+          <a:xfrm>
+            <a:off x="877824" y="2450592"/>
+            <a:ext cx="420624" cy="420624"/>
+          </a:xfrm>
+          <a:prstGeom prst="ellipse">
+            <a:avLst/>
+          </a:prstGeom>
+          <a:solidFill>
+            <a:srgbClr val="12AEBE"/>
+          </a:solidFill>
+          <a:ln/>
+        </p:spPr>
+      </p:sp>
+      <p:sp>
+        <p:nvSpPr>
+          <p:cNvPr id="8" name="Text 5"/>
+          <p:cNvSpPr/>
+          <p:nvPr/>
+        </p:nvSpPr>
+        <p:spPr>
+          <a:xfrm>
+            <a:off x="877824" y="2450592"/>
+            <a:ext cx="420624" cy="420624"/>
+          </a:xfrm>
+          <a:prstGeom prst="rect">
+            <a:avLst/>
+          </a:prstGeom>
+          <a:noFill/>
+          <a:ln/>
+        </p:spPr>
+        <p:txBody>
+          <a:bodyPr wrap="square" lIns="0" tIns="0" rIns="0" bIns="0" rtlCol="0" anchor="ctr"/>
+          <a:lstStyle/>
+          <a:p>
+            <a:pPr algn="ctr" indent="0" marL="0">
+              <a:buNone/>
+            </a:pPr>
+            <a:r>
+              <a:rPr lang="en-US" sz="1500" b="1" dirty="0">
+                <a:solidFill>
+                  <a:srgbClr val="FFFFFF"/>
+                </a:solidFill>
+                <a:latin typeface="Calibri" pitchFamily="34" charset="0"/>
+                <a:ea typeface="Calibri" pitchFamily="34" charset="-122"/>
+                <a:cs typeface="Calibri" pitchFamily="34" charset="-120"/>
+              </a:rPr>
+              <a:t>1</a:t>
+            </a:r>
+            <a:endParaRPr lang="en-US" sz="1500" dirty="0"/>
+          </a:p>
+        </p:txBody>
+      </p:sp>
+      <p:sp>
+        <p:nvSpPr>
+          <p:cNvPr id="9" name="Text 6"/>
+          <p:cNvSpPr/>
+          <p:nvPr/>
+        </p:nvSpPr>
+        <p:spPr>
+          <a:xfrm>
+            <a:off x="877824" y="3090672"/>
+            <a:ext cx="2761488" cy="365760"/>
+          </a:xfrm>
+          <a:prstGeom prst="rect">
+            <a:avLst/>
+          </a:prstGeom>
+          <a:noFill/>
+          <a:ln/>
+        </p:spPr>
+        <p:txBody>
+          <a:bodyPr wrap="square" lIns="0" tIns="0" rIns="0" bIns="0" rtlCol="0" anchor="ctr"/>
+          <a:lstStyle/>
+          <a:p>
+            <a:pPr indent="0" marL="0">
+              <a:buNone/>
+            </a:pPr>
+            <a:r>
+              <a:rPr lang="en-US" sz="1900" b="1" dirty="0">
+                <a:solidFill>
+                  <a:srgbClr val="0A4B75"/>
+                </a:solidFill>
+                <a:latin typeface="Calibri" pitchFamily="34" charset="0"/>
+                <a:ea typeface="Calibri" pitchFamily="34" charset="-122"/>
+                <a:cs typeface="Calibri" pitchFamily="34" charset="-120"/>
+              </a:rPr>
+              <a:t>Heading</a:t>
+            </a:r>
+            <a:endParaRPr lang="en-US" sz="1900" dirty="0"/>
+          </a:p>
+        </p:txBody>
+      </p:sp>
+      <p:sp>
+        <p:nvSpPr>
+          <p:cNvPr id="10" name="Text 7"/>
+          <p:cNvSpPr/>
+          <p:nvPr/>
+        </p:nvSpPr>
+        <p:spPr>
+          <a:xfrm>
+            <a:off x="877824" y="3584448"/>
+            <a:ext cx="2761488" cy="1463040"/>
+          </a:xfrm>
+          <a:prstGeom prst="rect">
+            <a:avLst/>
+          </a:prstGeom>
+          <a:noFill/>
+          <a:ln/>
+        </p:spPr>
+        <p:txBody>
+          <a:bodyPr wrap="square" lIns="0" tIns="0" rIns="0" bIns="0" rtlCol="0" anchor="t"/>
+          <a:lstStyle/>
+          <a:p>
+            <a:pPr indent="0" marL="0">
+              <a:lnSpc>
+                <a:spcPts val="1900"/>
+              </a:lnSpc>
+              <a:buNone/>
+            </a:pPr>
+            <a:r>
+              <a:rPr lang="en-US" sz="1350" dirty="0">
+                <a:solidFill>
+                  <a:srgbClr val="53606A"/>
+                </a:solidFill>
+                <a:latin typeface="Calibri" pitchFamily="34" charset="0"/>
+                <a:ea typeface="Calibri" pitchFamily="34" charset="-122"/>
+                <a:cs typeface="Calibri" pitchFamily="34" charset="-120"/>
+              </a:rPr>
+              <a:t>Add your point here.</a:t>
+            </a:r>
+            <a:endParaRPr lang="en-US" sz="1350" dirty="0"/>
+          </a:p>
+        </p:txBody>
+      </p:sp>
+      <p:sp>
+        <p:nvSpPr>
+          <p:cNvPr id="11" name="Shape 8"/>
+          <p:cNvSpPr/>
+          <p:nvPr/>
+        </p:nvSpPr>
+        <p:spPr>
+          <a:xfrm>
+            <a:off x="4279392" y="2157984"/>
+            <a:ext cx="3383280" cy="3200400"/>
+          </a:xfrm>
+          <a:prstGeom prst="roundRect">
+            <a:avLst>
+              <a:gd name="adj" fmla="val 2286"/>
+            </a:avLst>
+          </a:prstGeom>
+          <a:solidFill>
+            <a:srgbClr val="F2F6F9"/>
+          </a:solidFill>
+          <a:ln w="12700">
+            <a:solidFill>
+              <a:srgbClr val="DCE7EF"/>
+            </a:solidFill>
+            <a:prstDash val="solid"/>
+          </a:ln>
+        </p:spPr>
+      </p:sp>
+      <p:sp>
+        <p:nvSpPr>
+          <p:cNvPr id="12" name="Shape 9"/>
+          <p:cNvSpPr/>
+          <p:nvPr/>
+        </p:nvSpPr>
+        <p:spPr>
+          <a:xfrm>
+            <a:off x="4590288" y="2450592"/>
+            <a:ext cx="420624" cy="420624"/>
+          </a:xfrm>
+          <a:prstGeom prst="ellipse">
+            <a:avLst/>
+          </a:prstGeom>
+          <a:solidFill>
+            <a:srgbClr val="12AEBE"/>
+          </a:solidFill>
+          <a:ln/>
+        </p:spPr>
+      </p:sp>
+      <p:sp>
+        <p:nvSpPr>
+          <p:cNvPr id="13" name="Text 10"/>
+          <p:cNvSpPr/>
+          <p:nvPr/>
+        </p:nvSpPr>
+        <p:spPr>
+          <a:xfrm>
+            <a:off x="4590288" y="2450592"/>
+            <a:ext cx="420624" cy="420624"/>
+          </a:xfrm>
+          <a:prstGeom prst="rect">
+            <a:avLst/>
+          </a:prstGeom>
+          <a:noFill/>
+          <a:ln/>
+        </p:spPr>
+        <p:txBody>
+          <a:bodyPr wrap="square" lIns="0" tIns="0" rIns="0" bIns="0" rtlCol="0" anchor="ctr"/>
+          <a:lstStyle/>
+          <a:p>
+            <a:pPr algn="ctr" indent="0" marL="0">
+              <a:buNone/>
+            </a:pPr>
+            <a:r>
+              <a:rPr lang="en-US" sz="1500" b="1" dirty="0">
+                <a:solidFill>
+                  <a:srgbClr val="FFFFFF"/>
+                </a:solidFill>
+                <a:latin typeface="Calibri" pitchFamily="34" charset="0"/>
+                <a:ea typeface="Calibri" pitchFamily="34" charset="-122"/>
+                <a:cs typeface="Calibri" pitchFamily="34" charset="-120"/>
+              </a:rPr>
+              <a:t>2</a:t>
+            </a:r>
+            <a:endParaRPr lang="en-US" sz="1500" dirty="0"/>
+          </a:p>
+        </p:txBody>
+      </p:sp>
+      <p:sp>
+        <p:nvSpPr>
+          <p:cNvPr id="14" name="Text 11"/>
+          <p:cNvSpPr/>
+          <p:nvPr/>
+        </p:nvSpPr>
+        <p:spPr>
+          <a:xfrm>
+            <a:off x="4590288" y="3090672"/>
+            <a:ext cx="2761488" cy="365760"/>
+          </a:xfrm>
+          <a:prstGeom prst="rect">
+            <a:avLst/>
+          </a:prstGeom>
+          <a:noFill/>
+          <a:ln/>
+        </p:spPr>
+        <p:txBody>
+          <a:bodyPr wrap="square" lIns="0" tIns="0" rIns="0" bIns="0" rtlCol="0" anchor="ctr"/>
+          <a:lstStyle/>
+          <a:p>
+            <a:pPr indent="0" marL="0">
+              <a:buNone/>
+            </a:pPr>
+            <a:r>
+              <a:rPr lang="en-US" sz="1900" b="1" dirty="0">
+                <a:solidFill>
+                  <a:srgbClr val="0A4B75"/>
+                </a:solidFill>
+                <a:latin typeface="Calibri" pitchFamily="34" charset="0"/>
+                <a:ea typeface="Calibri" pitchFamily="34" charset="-122"/>
+                <a:cs typeface="Calibri" pitchFamily="34" charset="-120"/>
+              </a:rPr>
+              <a:t>Heading</a:t>
+            </a:r>
+            <a:endParaRPr lang="en-US" sz="1900" dirty="0"/>
+          </a:p>
+        </p:txBody>
+      </p:sp>
+      <p:sp>
+        <p:nvSpPr>
+          <p:cNvPr id="15" name="Text 12"/>
+          <p:cNvSpPr/>
+          <p:nvPr/>
+        </p:nvSpPr>
+        <p:spPr>
+          <a:xfrm>
+            <a:off x="4590288" y="3584448"/>
+            <a:ext cx="2761488" cy="1463040"/>
+          </a:xfrm>
+          <a:prstGeom prst="rect">
+            <a:avLst/>
+          </a:prstGeom>
+          <a:noFill/>
+          <a:ln/>
+        </p:spPr>
+        <p:txBody>
+          <a:bodyPr wrap="square" lIns="0" tIns="0" rIns="0" bIns="0" rtlCol="0" anchor="t"/>
+          <a:lstStyle/>
+          <a:p>
+            <a:pPr indent="0" marL="0">
+              <a:lnSpc>
+                <a:spcPts val="1900"/>
+              </a:lnSpc>
+              <a:buNone/>
+            </a:pPr>
+            <a:r>
+              <a:rPr lang="en-US" sz="1350" dirty="0">
+                <a:solidFill>
+                  <a:srgbClr val="53606A"/>
+                </a:solidFill>
+                <a:latin typeface="Calibri" pitchFamily="34" charset="0"/>
+                <a:ea typeface="Calibri" pitchFamily="34" charset="-122"/>
+                <a:cs typeface="Calibri" pitchFamily="34" charset="-120"/>
+              </a:rPr>
+              <a:t>Add your point here.</a:t>
+            </a:r>
+            <a:endParaRPr lang="en-US" sz="1350" dirty="0"/>
+          </a:p>
+        </p:txBody>
+      </p:sp>
+      <p:sp>
+        <p:nvSpPr>
+          <p:cNvPr id="16" name="Shape 13"/>
+          <p:cNvSpPr/>
+          <p:nvPr/>
+        </p:nvSpPr>
+        <p:spPr>
+          <a:xfrm>
+            <a:off x="7991856" y="2157984"/>
+            <a:ext cx="3383280" cy="3200400"/>
+          </a:xfrm>
+          <a:prstGeom prst="roundRect">
+            <a:avLst>
+              <a:gd name="adj" fmla="val 2286"/>
+            </a:avLst>
+          </a:prstGeom>
+          <a:solidFill>
+            <a:srgbClr val="F2F6F9"/>
+          </a:solidFill>
+          <a:ln w="12700">
+            <a:solidFill>
+              <a:srgbClr val="DCE7EF"/>
+            </a:solidFill>
+            <a:prstDash val="solid"/>
+          </a:ln>
+        </p:spPr>
+      </p:sp>
+      <p:sp>
+        <p:nvSpPr>
+          <p:cNvPr id="17" name="Shape 14"/>
+          <p:cNvSpPr/>
+          <p:nvPr/>
+        </p:nvSpPr>
+        <p:spPr>
+          <a:xfrm>
+            <a:off x="8302752" y="2450592"/>
+            <a:ext cx="420624" cy="420624"/>
+          </a:xfrm>
+          <a:prstGeom prst="ellipse">
+            <a:avLst/>
+          </a:prstGeom>
+          <a:solidFill>
+            <a:srgbClr val="12AEBE"/>
+          </a:solidFill>
+          <a:ln/>
+        </p:spPr>
+      </p:sp>
+      <p:sp>
+        <p:nvSpPr>
+          <p:cNvPr id="18" name="Text 15"/>
+          <p:cNvSpPr/>
+          <p:nvPr/>
+        </p:nvSpPr>
+        <p:spPr>
+          <a:xfrm>
+            <a:off x="8302752" y="2450592"/>
+            <a:ext cx="420624" cy="420624"/>
+          </a:xfrm>
+          <a:prstGeom prst="rect">
+            <a:avLst/>
+          </a:prstGeom>
+          <a:noFill/>
+          <a:ln/>
+        </p:spPr>
+        <p:txBody>
+          <a:bodyPr wrap="square" lIns="0" tIns="0" rIns="0" bIns="0" rtlCol="0" anchor="ctr"/>
+          <a:lstStyle/>
+          <a:p>
+            <a:pPr algn="ctr" indent="0" marL="0">
+              <a:buNone/>
+            </a:pPr>
+            <a:r>
+              <a:rPr lang="en-US" sz="1500" b="1" dirty="0">
+                <a:solidFill>
+                  <a:srgbClr val="FFFFFF"/>
+                </a:solidFill>
+                <a:latin typeface="Calibri" pitchFamily="34" charset="0"/>
+                <a:ea typeface="Calibri" pitchFamily="34" charset="-122"/>
+                <a:cs typeface="Calibri" pitchFamily="34" charset="-120"/>
+              </a:rPr>
+              <a:t>3</a:t>
+            </a:r>
+            <a:endParaRPr lang="en-US" sz="1500" dirty="0"/>
+          </a:p>
+        </p:txBody>
+      </p:sp>
+      <p:sp>
+        <p:nvSpPr>
+          <p:cNvPr id="19" name="Text 16"/>
+          <p:cNvSpPr/>
+          <p:nvPr/>
+        </p:nvSpPr>
+        <p:spPr>
+          <a:xfrm>
+            <a:off x="8302752" y="3090672"/>
+            <a:ext cx="2761488" cy="365760"/>
+          </a:xfrm>
+          <a:prstGeom prst="rect">
+            <a:avLst/>
+          </a:prstGeom>
+          <a:noFill/>
+          <a:ln/>
+        </p:spPr>
+        <p:txBody>
+          <a:bodyPr wrap="square" lIns="0" tIns="0" rIns="0" bIns="0" rtlCol="0" anchor="ctr"/>
+          <a:lstStyle/>
+          <a:p>
+            <a:pPr indent="0" marL="0">
+              <a:buNone/>
+            </a:pPr>
+            <a:r>
+              <a:rPr lang="en-US" sz="1900" b="1" dirty="0">
+                <a:solidFill>
+                  <a:srgbClr val="0A4B75"/>
+                </a:solidFill>
+                <a:latin typeface="Calibri" pitchFamily="34" charset="0"/>
+                <a:ea typeface="Calibri" pitchFamily="34" charset="-122"/>
+                <a:cs typeface="Calibri" pitchFamily="34" charset="-120"/>
+              </a:rPr>
+              <a:t>Heading</a:t>
+            </a:r>
+            <a:endParaRPr lang="en-US" sz="1900" dirty="0"/>
+          </a:p>
+        </p:txBody>
+      </p:sp>
+      <p:sp>
+        <p:nvSpPr>
+          <p:cNvPr id="20" name="Text 17"/>
+          <p:cNvSpPr/>
+          <p:nvPr/>
+        </p:nvSpPr>
+        <p:spPr>
+          <a:xfrm>
+            <a:off x="8302752" y="3584448"/>
+            <a:ext cx="2761488" cy="1463040"/>
+          </a:xfrm>
+          <a:prstGeom prst="rect">
+            <a:avLst/>
+          </a:prstGeom>
+          <a:noFill/>
+          <a:ln/>
+        </p:spPr>
+        <p:txBody>
+          <a:bodyPr wrap="square" lIns="0" tIns="0" rIns="0" bIns="0" rtlCol="0" anchor="t"/>
+          <a:lstStyle/>
+          <a:p>
+            <a:pPr indent="0" marL="0">
+              <a:lnSpc>
+                <a:spcPts val="1900"/>
+              </a:lnSpc>
+              <a:buNone/>
+            </a:pPr>
+            <a:r>
+              <a:rPr lang="en-US" sz="1350" dirty="0">
+                <a:solidFill>
+                  <a:srgbClr val="53606A"/>
+                </a:solidFill>
+                <a:latin typeface="Calibri" pitchFamily="34" charset="0"/>
+                <a:ea typeface="Calibri" pitchFamily="34" charset="-122"/>
+                <a:cs typeface="Calibri" pitchFamily="34" charset="-120"/>
+              </a:rPr>
+              <a:t>Add your point here.</a:t>
+            </a:r>
+            <a:endParaRPr lang="en-US" sz="1350" dirty="0"/>
+          </a:p>
+        </p:txBody>
+      </p:sp>
+      <p:sp>
+        <p:nvSpPr>
+          <p:cNvPr id="21" name="Text 18"/>
+          <p:cNvSpPr/>
+          <p:nvPr/>
+        </p:nvSpPr>
+        <p:spPr>
+          <a:xfrm>
+            <a:off x="566928" y="5669280"/>
+            <a:ext cx="10515600" cy="365760"/>
+          </a:xfrm>
+          <a:prstGeom prst="rect">
+            <a:avLst/>
+          </a:prstGeom>
+          <a:noFill/>
+          <a:ln/>
+        </p:spPr>
+        <p:txBody>
+          <a:bodyPr wrap="square" lIns="0" tIns="0" rIns="0" bIns="0" rtlCol="0" anchor="ctr"/>
+          <a:lstStyle/>
+          <a:p>
+            <a:pPr indent="0" marL="0">
+              <a:buNone/>
+            </a:pPr>
+            <a:r>
+              <a:rPr lang="en-US" sz="1700" b="1" dirty="0">
+                <a:solidFill>
+                  <a:srgbClr val="0A4B75"/>
+                </a:solidFill>
+                <a:latin typeface="Calibri" pitchFamily="34" charset="0"/>
+                <a:ea typeface="Calibri" pitchFamily="34" charset="-122"/>
+                <a:cs typeface="Calibri" pitchFamily="34" charset="-120"/>
+              </a:rPr>
+              <a:t>Add a closing line here.</a:t>
+            </a:r>
+            <a:endParaRPr lang="en-US" sz="1700" dirty="0"/>
+          </a:p>
+        </p:txBody>
+      </p:sp>
+    </p:spTree>
+  </p:cSld>
+  <p:clrMapOvr>
+    <a:masterClrMapping/>
+  </p:clrMapOvr>
+</p:sld>
+</file>
+
+<file path=ppt/slides/slide18.xml><?xml version="1.0" encoding="utf-8"?>
+<p:sld xmlns:a="http://schemas.openxmlformats.org/drawingml/2006/main" xmlns:r="http://schemas.openxmlformats.org/officeDocument/2006/relationships" xmlns:p="http://schemas.openxmlformats.org/presentationml/2006/main">
+  <p:cSld name="Slide 18">
+    <p:bg>
+      <p:bgPr>
+        <a:solidFill>
           <a:srgbClr val="063049"/>
         </a:solidFill>
       </p:bgPr>
@@ -6340,45 +8881,6 @@
               <a:t>One page that says what is at risk, what it is worth, and what it would take to fix — from figures nobody retyped.</a:t>
             </a:r>
             <a:endParaRPr lang="en-US" sz="1350" dirty="0"/>
-          </a:p>
-        </p:txBody>
-      </p:sp>
-      <p:sp>
-        <p:nvSpPr>
-          <p:cNvPr id="17" name="Text 14"/>
-          <p:cNvSpPr/>
-          <p:nvPr/>
-        </p:nvSpPr>
-        <p:spPr>
-          <a:xfrm>
-            <a:off x="566928" y="5815584"/>
-            <a:ext cx="9326880" cy="457200"/>
-          </a:xfrm>
-          <a:prstGeom prst="rect">
-            <a:avLst/>
-          </a:prstGeom>
-          <a:noFill/>
-          <a:ln/>
-        </p:spPr>
-        <p:txBody>
-          <a:bodyPr wrap="square" lIns="0" tIns="0" rIns="0" bIns="0" rtlCol="0" anchor="ctr"/>
-          <a:lstStyle/>
-          <a:p>
-            <a:pPr indent="0" marL="0">
-              <a:buNone/>
-            </a:pPr>
-            <a:r>
-              <a:rPr lang="en-US" sz="1300" i="1" dirty="0">
-                <a:solidFill>
-                  <a:srgbClr val="7FA6C2"/>
-                </a:solidFill>
-                <a:latin typeface="Calibri" pitchFamily="34" charset="0"/>
-                <a:ea typeface="Calibri" pitchFamily="34" charset="-122"/>
-                <a:cs typeface="Calibri" pitchFamily="34" charset="-120"/>
-              </a:rPr>
-              <a:t>Next: shared storage so the portfolio follows you between machines — specified, costed at about a day.</a:t>
-            </a:r>
-            <a:endParaRPr lang="en-US" sz="1300" dirty="0"/>
           </a:p>
         </p:txBody>
       </p:sp>

</xml_diff>

<commit_message>
Let the light lockup fill its tile
The tile behind it was paper, so the sidebar's navy read as a box inside a box
while the dark tile ran edge to edge. The tile now takes the same navy the
sidebar does, and the two lockups are framed alike.

The generator can also build one slide on its own — same code, so a slide asked
for by name cannot drift from the deck it came out of.

Co-Authored-By: Claude Opus 5 <noreply@anthropic.com>
Claude-Session: https://claude.ai/code/session_01FAfQiDa3Xfo5qzKcvsbnuE
</commit_message>
<xml_diff>
--- a/docs/Project Glass — PMO Portfolio Tracker.pptx
+++ b/docs/Project Glass — PMO Portfolio Tracker.pptx
@@ -6427,11 +6427,11 @@
             </a:avLst>
           </a:prstGeom>
           <a:solidFill>
-            <a:srgbClr val="F2F6F9"/>
+            <a:srgbClr val="0A4B75"/>
           </a:solidFill>
           <a:ln w="12700">
             <a:solidFill>
-              <a:srgbClr val="D9E4EC"/>
+              <a:srgbClr val="0A4B75"/>
             </a:solidFill>
             <a:prstDash val="solid"/>
           </a:ln>

</xml_diff>